<commit_message>
docs(observability): switch presentation deck to light theme
Repalette the 7-slide deck to a light/white scheme (dark text on white cards,
colored header bands kept). Re-verified all slides via PowerPoint export.
</commit_message>
<xml_diff>
--- a/ops/observability/observability.pptx
+++ b/ops/observability/observability.pptx
@@ -155,7 +155,7 @@
                 <a:pPr>
                   <a:defRPr b="0" i="0" strike="noStrike" sz="1100" u="none">
                     <a:solidFill>
-                      <a:srgbClr val="EAF1FB"/>
+                      <a:srgbClr val="1E2A40"/>
                     </a:solidFill>
                     <a:latin typeface="Arial"/>
                   </a:defRPr>
@@ -217,7 +217,7 @@
               <a:pPr>
                 <a:defRPr b="0" i="0" strike="noStrike" sz="1100" u="none">
                   <a:solidFill>
-                    <a:srgbClr val="EAF1FB"/>
+                    <a:srgbClr val="1E2A40"/>
                   </a:solidFill>
                   <a:latin typeface="Arial"/>
                 </a:defRPr>
@@ -265,7 +265,7 @@
             <a:pPr>
               <a:defRPr sz="1000" b="0" i="0" u="none" strike="noStrike">
                 <a:solidFill>
-                  <a:srgbClr val="BCC8DA"/>
+                  <a:srgbClr val="44546D"/>
                 </a:solidFill>
                 <a:latin typeface="Arial"/>
               </a:defRPr>
@@ -290,7 +290,7 @@
           <c:spPr>
             <a:ln w="6350" cap="flat">
               <a:solidFill>
-                <a:srgbClr val="33415C"/>
+                <a:srgbClr val="D7E0EE"/>
               </a:solidFill>
               <a:prstDash val="solid"/>
               <a:round/>
@@ -317,7 +317,7 @@
             <a:pPr>
               <a:defRPr sz="900" b="0" i="0" u="none" strike="noStrike">
                 <a:solidFill>
-                  <a:srgbClr val="93A1B8"/>
+                  <a:srgbClr val="6E7C93"/>
                 </a:solidFill>
                 <a:latin typeface="Arial"/>
               </a:defRPr>
@@ -342,7 +342,7 @@
   </c:chart>
   <c:spPr>
     <a:solidFill>
-      <a:srgbClr val="1B2436"/>
+      <a:srgbClr val="FFFFFF"/>
     </a:solidFill>
     <a:ln>
       <a:noFill/>
@@ -1633,7 +1633,7 @@
     <p:bg>
       <p:bgPr>
         <a:solidFill>
-          <a:srgbClr val="0E1626"/>
+          <a:srgbClr val="F6F8FC"/>
         </a:solidFill>
       </p:bgPr>
     </p:bg>
@@ -1678,7 +1678,7 @@
             <a:r>
               <a:rPr lang="en-US" sz="1200" b="1" spc="300" kern="0" dirty="0">
                 <a:solidFill>
-                  <a:srgbClr val="38BDF8"/>
+                  <a:srgbClr val="0E9BD6"/>
                 </a:solidFill>
                 <a:latin typeface="Microsoft JhengHei" pitchFamily="34" charset="0"/>
                 <a:ea typeface="Microsoft JhengHei" pitchFamily="34" charset="-122"/>
@@ -1717,7 +1717,7 @@
             <a:r>
               <a:rPr lang="en-US" sz="3400" b="1" dirty="0">
                 <a:solidFill>
-                  <a:srgbClr val="EAF1FB"/>
+                  <a:srgbClr val="1E2A40"/>
                 </a:solidFill>
                 <a:latin typeface="Microsoft JhengHei" pitchFamily="34" charset="0"/>
                 <a:ea typeface="Microsoft JhengHei" pitchFamily="34" charset="-122"/>
@@ -1756,7 +1756,7 @@
             <a:r>
               <a:rPr lang="en-US" sz="1400" dirty="0">
                 <a:solidFill>
-                  <a:srgbClr val="BCC8DA"/>
+                  <a:srgbClr val="44546D"/>
                 </a:solidFill>
                 <a:latin typeface="Microsoft JhengHei" pitchFamily="34" charset="0"/>
                 <a:ea typeface="Microsoft JhengHei" pitchFamily="34" charset="-122"/>
@@ -1791,9 +1791,9 @@
             <a:avLst/>
           </a:prstGeom>
           <a:effectLst>
-            <a:outerShdw sx="100000" sy="100000" kx="0" ky="0" algn="bl" rotWithShape="0" blurRad="114300" dist="38100" dir="5400000">
-              <a:srgbClr val="000000">
-                <a:alpha val="32000"/>
+            <a:outerShdw sx="100000" sy="100000" kx="0" ky="0" algn="bl" rotWithShape="0" blurRad="88900" dist="25400" dir="5400000">
+              <a:srgbClr val="8895AC">
+                <a:alpha val="28000"/>
               </a:srgbClr>
             </a:outerShdw>
           </a:effectLst>
@@ -1816,7 +1816,7 @@
           <a:noFill/>
           <a:ln w="12700">
             <a:solidFill>
-              <a:srgbClr val="33415C"/>
+              <a:srgbClr val="D7E0EE"/>
             </a:solidFill>
             <a:prstDash val="solid"/>
           </a:ln>
@@ -1849,7 +1849,7 @@
             <a:r>
               <a:rPr lang="en-US" sz="900" dirty="0">
                 <a:solidFill>
-                  <a:srgbClr val="93A1B8"/>
+                  <a:srgbClr val="6E7C93"/>
                 </a:solidFill>
                 <a:latin typeface="Microsoft JhengHei" pitchFamily="34" charset="0"/>
                 <a:ea typeface="Microsoft JhengHei" pitchFamily="34" charset="-122"/>
@@ -1888,7 +1888,7 @@
             <a:r>
               <a:rPr lang="en-US" sz="900" dirty="0">
                 <a:solidFill>
-                  <a:srgbClr val="93A1B8"/>
+                  <a:srgbClr val="6E7C93"/>
                 </a:solidFill>
                 <a:latin typeface="Microsoft JhengHei" pitchFamily="34" charset="0"/>
                 <a:ea typeface="Microsoft JhengHei" pitchFamily="34" charset="-122"/>
@@ -1914,7 +1914,7 @@
     <p:bg>
       <p:bgPr>
         <a:solidFill>
-          <a:srgbClr val="0E1626"/>
+          <a:srgbClr val="F6F8FC"/>
         </a:solidFill>
       </p:bgPr>
     </p:bg>
@@ -1947,7 +1947,7 @@
             <a:avLst/>
           </a:prstGeom>
           <a:solidFill>
-            <a:srgbClr val="38BDF8"/>
+            <a:srgbClr val="0E9BD6"/>
           </a:solidFill>
           <a:ln/>
         </p:spPr>
@@ -1967,13 +1967,13 @@
             <a:avLst/>
           </a:prstGeom>
           <a:solidFill>
-            <a:srgbClr val="38BDF8"/>
+            <a:srgbClr val="0E9BD6"/>
           </a:solidFill>
           <a:ln/>
           <a:effectLst>
-            <a:outerShdw sx="100000" sy="100000" kx="0" ky="0" algn="bl" rotWithShape="0" blurRad="114300" dist="38100" dir="5400000">
-              <a:srgbClr val="000000">
-                <a:alpha val="32000"/>
+            <a:outerShdw sx="100000" sy="100000" kx="0" ky="0" algn="bl" rotWithShape="0" blurRad="88900" dist="25400" dir="5400000">
+              <a:srgbClr val="8895AC">
+                <a:alpha val="28000"/>
               </a:srgbClr>
             </a:outerShdw>
           </a:effectLst>
@@ -2006,7 +2006,7 @@
             <a:r>
               <a:rPr lang="en-US" sz="2600" b="1" dirty="0">
                 <a:solidFill>
-                  <a:srgbClr val="0E1626"/>
+                  <a:srgbClr val="FFFFFF"/>
                 </a:solidFill>
                 <a:latin typeface="Microsoft JhengHei" pitchFamily="34" charset="0"/>
                 <a:ea typeface="Microsoft JhengHei" pitchFamily="34" charset="-122"/>
@@ -2045,7 +2045,7 @@
             <a:r>
               <a:rPr lang="en-US" sz="1250" b="1" spc="300" kern="0" dirty="0">
                 <a:solidFill>
-                  <a:srgbClr val="38BDF8"/>
+                  <a:srgbClr val="0E9BD6"/>
                 </a:solidFill>
                 <a:latin typeface="Microsoft JhengHei" pitchFamily="34" charset="0"/>
                 <a:ea typeface="Microsoft JhengHei" pitchFamily="34" charset="-122"/>
@@ -2084,7 +2084,7 @@
             <a:r>
               <a:rPr lang="en-US" sz="2900" b="1" dirty="0">
                 <a:solidFill>
-                  <a:srgbClr val="EAF1FB"/>
+                  <a:srgbClr val="1E2A40"/>
                 </a:solidFill>
                 <a:latin typeface="Microsoft JhengHei" pitchFamily="34" charset="0"/>
                 <a:ea typeface="Microsoft JhengHei" pitchFamily="34" charset="-122"/>
@@ -2123,7 +2123,7 @@
             <a:r>
               <a:rPr lang="en-US" sz="1300" dirty="0">
                 <a:solidFill>
-                  <a:srgbClr val="BCC8DA"/>
+                  <a:srgbClr val="44546D"/>
                 </a:solidFill>
                 <a:latin typeface="Microsoft JhengHei" pitchFamily="34" charset="0"/>
                 <a:ea typeface="Microsoft JhengHei" pitchFamily="34" charset="-122"/>
@@ -2152,18 +2152,18 @@
             </a:avLst>
           </a:prstGeom>
           <a:solidFill>
-            <a:srgbClr val="1B2436"/>
+            <a:srgbClr val="FFFFFF"/>
           </a:solidFill>
           <a:ln w="12700">
             <a:solidFill>
-              <a:srgbClr val="33415C"/>
+              <a:srgbClr val="D7E0EE"/>
             </a:solidFill>
             <a:prstDash val="solid"/>
           </a:ln>
           <a:effectLst>
-            <a:outerShdw sx="100000" sy="100000" kx="0" ky="0" algn="bl" rotWithShape="0" blurRad="114300" dist="38100" dir="5400000">
-              <a:srgbClr val="000000">
-                <a:alpha val="32000"/>
+            <a:outerShdw sx="100000" sy="100000" kx="0" ky="0" algn="bl" rotWithShape="0" blurRad="88900" dist="25400" dir="5400000">
+              <a:srgbClr val="8895AC">
+                <a:alpha val="28000"/>
               </a:srgbClr>
             </a:outerShdw>
           </a:effectLst>
@@ -2184,7 +2184,7 @@
             <a:avLst/>
           </a:prstGeom>
           <a:solidFill>
-            <a:srgbClr val="38BDF8"/>
+            <a:srgbClr val="0E9BD6"/>
           </a:solidFill>
           <a:ln/>
         </p:spPr>
@@ -2216,7 +2216,7 @@
             <a:r>
               <a:rPr lang="en-US" sz="1500" b="1" dirty="0">
                 <a:solidFill>
-                  <a:srgbClr val="EAF1FB"/>
+                  <a:srgbClr val="1E2A40"/>
                 </a:solidFill>
                 <a:latin typeface="Microsoft JhengHei" pitchFamily="34" charset="0"/>
                 <a:ea typeface="Microsoft JhengHei" pitchFamily="34" charset="-122"/>
@@ -2259,7 +2259,7 @@
             <a:r>
               <a:rPr lang="en-US" sz="1250" dirty="0">
                 <a:solidFill>
-                  <a:srgbClr val="BCC8DA"/>
+                  <a:srgbClr val="44546D"/>
                 </a:solidFill>
                 <a:latin typeface="Microsoft JhengHei" pitchFamily="34" charset="0"/>
                 <a:ea typeface="Microsoft JhengHei" pitchFamily="34" charset="-122"/>
@@ -2280,7 +2280,7 @@
             <a:r>
               <a:rPr lang="en-US" sz="1250" dirty="0">
                 <a:solidFill>
-                  <a:srgbClr val="BCC8DA"/>
+                  <a:srgbClr val="44546D"/>
                 </a:solidFill>
                 <a:latin typeface="Microsoft JhengHei" pitchFamily="34" charset="0"/>
                 <a:ea typeface="Microsoft JhengHei" pitchFamily="34" charset="-122"/>
@@ -2309,18 +2309,18 @@
             </a:avLst>
           </a:prstGeom>
           <a:solidFill>
-            <a:srgbClr val="1B2436"/>
+            <a:srgbClr val="FFFFFF"/>
           </a:solidFill>
           <a:ln w="12700">
             <a:solidFill>
-              <a:srgbClr val="33415C"/>
+              <a:srgbClr val="D7E0EE"/>
             </a:solidFill>
             <a:prstDash val="solid"/>
           </a:ln>
           <a:effectLst>
-            <a:outerShdw sx="100000" sy="100000" kx="0" ky="0" algn="bl" rotWithShape="0" blurRad="114300" dist="38100" dir="5400000">
-              <a:srgbClr val="000000">
-                <a:alpha val="32000"/>
+            <a:outerShdw sx="100000" sy="100000" kx="0" ky="0" algn="bl" rotWithShape="0" blurRad="88900" dist="25400" dir="5400000">
+              <a:srgbClr val="8895AC">
+                <a:alpha val="28000"/>
               </a:srgbClr>
             </a:outerShdw>
           </a:effectLst>
@@ -2341,7 +2341,7 @@
             <a:avLst/>
           </a:prstGeom>
           <a:solidFill>
-            <a:srgbClr val="38BDF8"/>
+            <a:srgbClr val="0E9BD6"/>
           </a:solidFill>
           <a:ln/>
         </p:spPr>
@@ -2373,7 +2373,7 @@
             <a:r>
               <a:rPr lang="en-US" sz="1500" b="1" dirty="0">
                 <a:solidFill>
-                  <a:srgbClr val="EAF1FB"/>
+                  <a:srgbClr val="1E2A40"/>
                 </a:solidFill>
                 <a:latin typeface="Microsoft JhengHei" pitchFamily="34" charset="0"/>
                 <a:ea typeface="Microsoft JhengHei" pitchFamily="34" charset="-122"/>
@@ -2400,7 +2400,7 @@
             <a:avLst/>
           </a:prstGeom>
           <a:solidFill>
-            <a:srgbClr val="4A86D4"/>
+            <a:srgbClr val="2F6FC0"/>
           </a:solidFill>
           <a:ln/>
         </p:spPr>
@@ -2432,7 +2432,7 @@
             <a:r>
               <a:rPr lang="en-US" sz="1150" b="1" dirty="0">
                 <a:solidFill>
-                  <a:srgbClr val="EAF1FB"/>
+                  <a:srgbClr val="1E2A40"/>
                 </a:solidFill>
                 <a:latin typeface="Consolas" pitchFamily="34" charset="0"/>
                 <a:ea typeface="Consolas" pitchFamily="34" charset="-122"/>
@@ -2446,7 +2446,7 @@
             <a:r>
               <a:rPr lang="en-US" sz="1150" dirty="0">
                 <a:solidFill>
-                  <a:srgbClr val="93A1B8"/>
+                  <a:srgbClr val="6E7C93"/>
                 </a:solidFill>
                 <a:latin typeface="Microsoft JhengHei" pitchFamily="34" charset="0"/>
                 <a:ea typeface="Microsoft JhengHei" pitchFamily="34" charset="-122"/>
@@ -2473,7 +2473,7 @@
             <a:avLst/>
           </a:prstGeom>
           <a:solidFill>
-            <a:srgbClr val="36A06A"/>
+            <a:srgbClr val="2E9460"/>
           </a:solidFill>
           <a:ln/>
         </p:spPr>
@@ -2505,7 +2505,7 @@
             <a:r>
               <a:rPr lang="en-US" sz="1150" b="1" dirty="0">
                 <a:solidFill>
-                  <a:srgbClr val="EAF1FB"/>
+                  <a:srgbClr val="1E2A40"/>
                 </a:solidFill>
                 <a:latin typeface="Consolas" pitchFamily="34" charset="0"/>
                 <a:ea typeface="Consolas" pitchFamily="34" charset="-122"/>
@@ -2519,7 +2519,7 @@
             <a:r>
               <a:rPr lang="en-US" sz="1150" dirty="0">
                 <a:solidFill>
-                  <a:srgbClr val="93A1B8"/>
+                  <a:srgbClr val="6E7C93"/>
                 </a:solidFill>
                 <a:latin typeface="Microsoft JhengHei" pitchFamily="34" charset="0"/>
                 <a:ea typeface="Microsoft JhengHei" pitchFamily="34" charset="-122"/>
@@ -2546,7 +2546,7 @@
             <a:avLst/>
           </a:prstGeom>
           <a:solidFill>
-            <a:srgbClr val="38BDF8"/>
+            <a:srgbClr val="0E9BD6"/>
           </a:solidFill>
           <a:ln/>
         </p:spPr>
@@ -2578,7 +2578,7 @@
             <a:r>
               <a:rPr lang="en-US" sz="1150" b="1" dirty="0">
                 <a:solidFill>
-                  <a:srgbClr val="EAF1FB"/>
+                  <a:srgbClr val="1E2A40"/>
                 </a:solidFill>
                 <a:latin typeface="Consolas" pitchFamily="34" charset="0"/>
                 <a:ea typeface="Consolas" pitchFamily="34" charset="-122"/>
@@ -2592,7 +2592,7 @@
             <a:r>
               <a:rPr lang="en-US" sz="1150" dirty="0">
                 <a:solidFill>
-                  <a:srgbClr val="93A1B8"/>
+                  <a:srgbClr val="6E7C93"/>
                 </a:solidFill>
                 <a:latin typeface="Microsoft JhengHei" pitchFamily="34" charset="0"/>
                 <a:ea typeface="Microsoft JhengHei" pitchFamily="34" charset="-122"/>
@@ -2619,7 +2619,7 @@
             <a:avLst/>
           </a:prstGeom>
           <a:solidFill>
-            <a:srgbClr val="E8923E"/>
+            <a:srgbClr val="D9791C"/>
           </a:solidFill>
           <a:ln/>
         </p:spPr>
@@ -2651,7 +2651,7 @@
             <a:r>
               <a:rPr lang="en-US" sz="1150" b="1" dirty="0">
                 <a:solidFill>
-                  <a:srgbClr val="EAF1FB"/>
+                  <a:srgbClr val="1E2A40"/>
                 </a:solidFill>
                 <a:latin typeface="Consolas" pitchFamily="34" charset="0"/>
                 <a:ea typeface="Consolas" pitchFamily="34" charset="-122"/>
@@ -2665,7 +2665,7 @@
             <a:r>
               <a:rPr lang="en-US" sz="1150" dirty="0">
                 <a:solidFill>
-                  <a:srgbClr val="93A1B8"/>
+                  <a:srgbClr val="6E7C93"/>
                 </a:solidFill>
                 <a:latin typeface="Microsoft JhengHei" pitchFamily="34" charset="0"/>
                 <a:ea typeface="Microsoft JhengHei" pitchFamily="34" charset="-122"/>
@@ -2692,7 +2692,7 @@
             <a:avLst/>
           </a:prstGeom>
           <a:solidFill>
-            <a:srgbClr val="9A5BD0"/>
+            <a:srgbClr val="8348B8"/>
           </a:solidFill>
           <a:ln/>
         </p:spPr>
@@ -2724,7 +2724,7 @@
             <a:r>
               <a:rPr lang="en-US" sz="1150" b="1" dirty="0">
                 <a:solidFill>
-                  <a:srgbClr val="EAF1FB"/>
+                  <a:srgbClr val="1E2A40"/>
                 </a:solidFill>
                 <a:latin typeface="Consolas" pitchFamily="34" charset="0"/>
                 <a:ea typeface="Consolas" pitchFamily="34" charset="-122"/>
@@ -2738,7 +2738,7 @@
             <a:r>
               <a:rPr lang="en-US" sz="1150" dirty="0">
                 <a:solidFill>
-                  <a:srgbClr val="93A1B8"/>
+                  <a:srgbClr val="6E7C93"/>
                 </a:solidFill>
                 <a:latin typeface="Microsoft JhengHei" pitchFamily="34" charset="0"/>
                 <a:ea typeface="Microsoft JhengHei" pitchFamily="34" charset="-122"/>
@@ -2767,18 +2767,18 @@
             </a:avLst>
           </a:prstGeom>
           <a:solidFill>
-            <a:srgbClr val="1B2436"/>
+            <a:srgbClr val="FFFFFF"/>
           </a:solidFill>
           <a:ln w="12700">
             <a:solidFill>
-              <a:srgbClr val="33415C"/>
+              <a:srgbClr val="D7E0EE"/>
             </a:solidFill>
             <a:prstDash val="solid"/>
           </a:ln>
           <a:effectLst>
-            <a:outerShdw sx="100000" sy="100000" kx="0" ky="0" algn="bl" rotWithShape="0" blurRad="114300" dist="38100" dir="5400000">
-              <a:srgbClr val="000000">
-                <a:alpha val="32000"/>
+            <a:outerShdw sx="100000" sy="100000" kx="0" ky="0" algn="bl" rotWithShape="0" blurRad="88900" dist="25400" dir="5400000">
+              <a:srgbClr val="8895AC">
+                <a:alpha val="28000"/>
               </a:srgbClr>
             </a:outerShdw>
           </a:effectLst>
@@ -2799,7 +2799,7 @@
             <a:avLst/>
           </a:prstGeom>
           <a:solidFill>
-            <a:srgbClr val="38BDF8"/>
+            <a:srgbClr val="0E9BD6"/>
           </a:solidFill>
           <a:ln/>
         </p:spPr>
@@ -2831,7 +2831,7 @@
             <a:r>
               <a:rPr lang="en-US" sz="1500" b="1" dirty="0">
                 <a:solidFill>
-                  <a:srgbClr val="EAF1FB"/>
+                  <a:srgbClr val="1E2A40"/>
                 </a:solidFill>
                 <a:latin typeface="Microsoft JhengHei" pitchFamily="34" charset="0"/>
                 <a:ea typeface="Microsoft JhengHei" pitchFamily="34" charset="-122"/>
@@ -2860,11 +2860,11 @@
             </a:avLst>
           </a:prstGeom>
           <a:solidFill>
-            <a:srgbClr val="232E44"/>
+            <a:srgbClr val="EDF3FB"/>
           </a:solidFill>
           <a:ln w="19050">
             <a:solidFill>
-              <a:srgbClr val="E8923E"/>
+              <a:srgbClr val="D9791C"/>
             </a:solidFill>
             <a:prstDash val="solid"/>
           </a:ln>
@@ -2897,7 +2897,7 @@
             <a:r>
               <a:rPr lang="en-US" sz="1150" b="1" dirty="0">
                 <a:solidFill>
-                  <a:srgbClr val="E8923E"/>
+                  <a:srgbClr val="D9791C"/>
                 </a:solidFill>
                 <a:latin typeface="Microsoft JhengHei" pitchFamily="34" charset="0"/>
                 <a:ea typeface="Microsoft JhengHei" pitchFamily="34" charset="-122"/>
@@ -2911,7 +2911,7 @@
             <a:r>
               <a:rPr lang="en-US" sz="1150" dirty="0">
                 <a:solidFill>
-                  <a:srgbClr val="BCC8DA"/>
+                  <a:srgbClr val="44546D"/>
                 </a:solidFill>
                 <a:latin typeface="Microsoft JhengHei" pitchFamily="34" charset="0"/>
                 <a:ea typeface="Microsoft JhengHei" pitchFamily="34" charset="-122"/>
@@ -2940,11 +2940,11 @@
             </a:avLst>
           </a:prstGeom>
           <a:solidFill>
-            <a:srgbClr val="232E44"/>
+            <a:srgbClr val="EDF3FB"/>
           </a:solidFill>
           <a:ln w="19050">
             <a:solidFill>
-              <a:srgbClr val="4A86D4"/>
+              <a:srgbClr val="2F6FC0"/>
             </a:solidFill>
             <a:prstDash val="solid"/>
           </a:ln>
@@ -2977,7 +2977,7 @@
             <a:r>
               <a:rPr lang="en-US" sz="1150" b="1" dirty="0">
                 <a:solidFill>
-                  <a:srgbClr val="4A86D4"/>
+                  <a:srgbClr val="2F6FC0"/>
                 </a:solidFill>
                 <a:latin typeface="Microsoft JhengHei" pitchFamily="34" charset="0"/>
                 <a:ea typeface="Microsoft JhengHei" pitchFamily="34" charset="-122"/>
@@ -2991,7 +2991,7 @@
             <a:r>
               <a:rPr lang="en-US" sz="1150" dirty="0">
                 <a:solidFill>
-                  <a:srgbClr val="BCC8DA"/>
+                  <a:srgbClr val="44546D"/>
                 </a:solidFill>
                 <a:latin typeface="Microsoft JhengHei" pitchFamily="34" charset="0"/>
                 <a:ea typeface="Microsoft JhengHei" pitchFamily="34" charset="-122"/>
@@ -3020,11 +3020,11 @@
             </a:avLst>
           </a:prstGeom>
           <a:solidFill>
-            <a:srgbClr val="232E44"/>
+            <a:srgbClr val="EDF3FB"/>
           </a:solidFill>
           <a:ln w="19050">
             <a:solidFill>
-              <a:srgbClr val="36A06A"/>
+              <a:srgbClr val="2E9460"/>
             </a:solidFill>
             <a:prstDash val="solid"/>
           </a:ln>
@@ -3057,7 +3057,7 @@
             <a:r>
               <a:rPr lang="en-US" sz="1150" b="1" dirty="0">
                 <a:solidFill>
-                  <a:srgbClr val="36A06A"/>
+                  <a:srgbClr val="2E9460"/>
                 </a:solidFill>
                 <a:latin typeface="Microsoft JhengHei" pitchFamily="34" charset="0"/>
                 <a:ea typeface="Microsoft JhengHei" pitchFamily="34" charset="-122"/>
@@ -3071,7 +3071,7 @@
             <a:r>
               <a:rPr lang="en-US" sz="1150" dirty="0">
                 <a:solidFill>
-                  <a:srgbClr val="BCC8DA"/>
+                  <a:srgbClr val="44546D"/>
                 </a:solidFill>
                 <a:latin typeface="Microsoft JhengHei" pitchFamily="34" charset="0"/>
                 <a:ea typeface="Microsoft JhengHei" pitchFamily="34" charset="-122"/>
@@ -3100,11 +3100,11 @@
             </a:avLst>
           </a:prstGeom>
           <a:solidFill>
-            <a:srgbClr val="232E44"/>
+            <a:srgbClr val="EDF3FB"/>
           </a:solidFill>
           <a:ln w="19050">
             <a:solidFill>
-              <a:srgbClr val="9A5BD0"/>
+              <a:srgbClr val="8348B8"/>
             </a:solidFill>
             <a:prstDash val="solid"/>
           </a:ln>
@@ -3137,7 +3137,7 @@
             <a:r>
               <a:rPr lang="en-US" sz="1150" b="1" dirty="0">
                 <a:solidFill>
-                  <a:srgbClr val="9A5BD0"/>
+                  <a:srgbClr val="8348B8"/>
                 </a:solidFill>
                 <a:latin typeface="Microsoft JhengHei" pitchFamily="34" charset="0"/>
                 <a:ea typeface="Microsoft JhengHei" pitchFamily="34" charset="-122"/>
@@ -3151,7 +3151,7 @@
             <a:r>
               <a:rPr lang="en-US" sz="1150" dirty="0">
                 <a:solidFill>
-                  <a:srgbClr val="BCC8DA"/>
+                  <a:srgbClr val="44546D"/>
                 </a:solidFill>
                 <a:latin typeface="Microsoft JhengHei" pitchFamily="34" charset="0"/>
                 <a:ea typeface="Microsoft JhengHei" pitchFamily="34" charset="-122"/>
@@ -3180,18 +3180,18 @@
             </a:avLst>
           </a:prstGeom>
           <a:solidFill>
-            <a:srgbClr val="1B2436"/>
+            <a:srgbClr val="FFFFFF"/>
           </a:solidFill>
           <a:ln w="12700">
             <a:solidFill>
-              <a:srgbClr val="33415C"/>
+              <a:srgbClr val="D7E0EE"/>
             </a:solidFill>
             <a:prstDash val="solid"/>
           </a:ln>
           <a:effectLst>
-            <a:outerShdw sx="100000" sy="100000" kx="0" ky="0" algn="bl" rotWithShape="0" blurRad="114300" dist="38100" dir="5400000">
-              <a:srgbClr val="000000">
-                <a:alpha val="32000"/>
+            <a:outerShdw sx="100000" sy="100000" kx="0" ky="0" algn="bl" rotWithShape="0" blurRad="88900" dist="25400" dir="5400000">
+              <a:srgbClr val="8895AC">
+                <a:alpha val="28000"/>
               </a:srgbClr>
             </a:outerShdw>
           </a:effectLst>
@@ -3212,7 +3212,7 @@
             <a:avLst/>
           </a:prstGeom>
           <a:solidFill>
-            <a:srgbClr val="38BDF8"/>
+            <a:srgbClr val="0E9BD6"/>
           </a:solidFill>
           <a:ln/>
         </p:spPr>
@@ -3244,7 +3244,7 @@
             <a:r>
               <a:rPr lang="en-US" sz="1500" b="1" dirty="0">
                 <a:solidFill>
-                  <a:srgbClr val="EAF1FB"/>
+                  <a:srgbClr val="1E2A40"/>
                 </a:solidFill>
                 <a:latin typeface="Microsoft JhengHei" pitchFamily="34" charset="0"/>
                 <a:ea typeface="Microsoft JhengHei" pitchFamily="34" charset="-122"/>
@@ -3287,7 +3287,7 @@
             <a:r>
               <a:rPr lang="en-US" sz="1250" dirty="0">
                 <a:solidFill>
-                  <a:srgbClr val="BCC8DA"/>
+                  <a:srgbClr val="44546D"/>
                 </a:solidFill>
                 <a:latin typeface="Microsoft JhengHei" pitchFamily="34" charset="0"/>
                 <a:ea typeface="Microsoft JhengHei" pitchFamily="34" charset="-122"/>
@@ -3308,7 +3308,7 @@
             <a:r>
               <a:rPr lang="en-US" sz="1250" dirty="0">
                 <a:solidFill>
-                  <a:srgbClr val="BCC8DA"/>
+                  <a:srgbClr val="44546D"/>
                 </a:solidFill>
                 <a:latin typeface="Microsoft JhengHei" pitchFamily="34" charset="0"/>
                 <a:ea typeface="Microsoft JhengHei" pitchFamily="34" charset="-122"/>
@@ -3329,7 +3329,7 @@
             <a:r>
               <a:rPr lang="en-US" sz="1250" dirty="0">
                 <a:solidFill>
-                  <a:srgbClr val="BCC8DA"/>
+                  <a:srgbClr val="44546D"/>
                 </a:solidFill>
                 <a:latin typeface="Microsoft JhengHei" pitchFamily="34" charset="0"/>
                 <a:ea typeface="Microsoft JhengHei" pitchFamily="34" charset="-122"/>
@@ -3358,7 +3358,7 @@
           <a:noFill/>
           <a:ln w="12700">
             <a:solidFill>
-              <a:srgbClr val="33415C"/>
+              <a:srgbClr val="D7E0EE"/>
             </a:solidFill>
             <a:prstDash val="solid"/>
           </a:ln>
@@ -3391,7 +3391,7 @@
             <a:r>
               <a:rPr lang="en-US" sz="900" dirty="0">
                 <a:solidFill>
-                  <a:srgbClr val="93A1B8"/>
+                  <a:srgbClr val="6E7C93"/>
                 </a:solidFill>
                 <a:latin typeface="Microsoft JhengHei" pitchFamily="34" charset="0"/>
                 <a:ea typeface="Microsoft JhengHei" pitchFamily="34" charset="-122"/>
@@ -3430,7 +3430,7 @@
             <a:r>
               <a:rPr lang="en-US" sz="900" dirty="0">
                 <a:solidFill>
-                  <a:srgbClr val="93A1B8"/>
+                  <a:srgbClr val="6E7C93"/>
                 </a:solidFill>
                 <a:latin typeface="Microsoft JhengHei" pitchFamily="34" charset="0"/>
                 <a:ea typeface="Microsoft JhengHei" pitchFamily="34" charset="-122"/>
@@ -3456,7 +3456,7 @@
     <p:bg>
       <p:bgPr>
         <a:solidFill>
-          <a:srgbClr val="0E1626"/>
+          <a:srgbClr val="F6F8FC"/>
         </a:solidFill>
       </p:bgPr>
     </p:bg>
@@ -3489,7 +3489,7 @@
             <a:avLst/>
           </a:prstGeom>
           <a:solidFill>
-            <a:srgbClr val="36A06A"/>
+            <a:srgbClr val="2E9460"/>
           </a:solidFill>
           <a:ln/>
         </p:spPr>
@@ -3509,13 +3509,13 @@
             <a:avLst/>
           </a:prstGeom>
           <a:solidFill>
-            <a:srgbClr val="36A06A"/>
+            <a:srgbClr val="2E9460"/>
           </a:solidFill>
           <a:ln/>
           <a:effectLst>
-            <a:outerShdw sx="100000" sy="100000" kx="0" ky="0" algn="bl" rotWithShape="0" blurRad="114300" dist="38100" dir="5400000">
-              <a:srgbClr val="000000">
-                <a:alpha val="32000"/>
+            <a:outerShdw sx="100000" sy="100000" kx="0" ky="0" algn="bl" rotWithShape="0" blurRad="88900" dist="25400" dir="5400000">
+              <a:srgbClr val="8895AC">
+                <a:alpha val="28000"/>
               </a:srgbClr>
             </a:outerShdw>
           </a:effectLst>
@@ -3548,7 +3548,7 @@
             <a:r>
               <a:rPr lang="en-US" sz="2600" b="1" dirty="0">
                 <a:solidFill>
-                  <a:srgbClr val="0E1626"/>
+                  <a:srgbClr val="FFFFFF"/>
                 </a:solidFill>
                 <a:latin typeface="Microsoft JhengHei" pitchFamily="34" charset="0"/>
                 <a:ea typeface="Microsoft JhengHei" pitchFamily="34" charset="-122"/>
@@ -3587,7 +3587,7 @@
             <a:r>
               <a:rPr lang="en-US" sz="1250" b="1" spc="300" kern="0" dirty="0">
                 <a:solidFill>
-                  <a:srgbClr val="36A06A"/>
+                  <a:srgbClr val="2E9460"/>
                 </a:solidFill>
                 <a:latin typeface="Microsoft JhengHei" pitchFamily="34" charset="0"/>
                 <a:ea typeface="Microsoft JhengHei" pitchFamily="34" charset="-122"/>
@@ -3626,7 +3626,7 @@
             <a:r>
               <a:rPr lang="en-US" sz="2900" b="1" dirty="0">
                 <a:solidFill>
-                  <a:srgbClr val="EAF1FB"/>
+                  <a:srgbClr val="1E2A40"/>
                 </a:solidFill>
                 <a:latin typeface="Microsoft JhengHei" pitchFamily="34" charset="0"/>
                 <a:ea typeface="Microsoft JhengHei" pitchFamily="34" charset="-122"/>
@@ -3655,18 +3655,18 @@
             </a:avLst>
           </a:prstGeom>
           <a:solidFill>
-            <a:srgbClr val="1B2436"/>
+            <a:srgbClr val="FFFFFF"/>
           </a:solidFill>
           <a:ln w="12700">
             <a:solidFill>
-              <a:srgbClr val="33415C"/>
+              <a:srgbClr val="D7E0EE"/>
             </a:solidFill>
             <a:prstDash val="solid"/>
           </a:ln>
           <a:effectLst>
-            <a:outerShdw sx="100000" sy="100000" kx="0" ky="0" algn="bl" rotWithShape="0" blurRad="114300" dist="38100" dir="5400000">
-              <a:srgbClr val="000000">
-                <a:alpha val="32000"/>
+            <a:outerShdw sx="100000" sy="100000" kx="0" ky="0" algn="bl" rotWithShape="0" blurRad="88900" dist="25400" dir="5400000">
+              <a:srgbClr val="8895AC">
+                <a:alpha val="28000"/>
               </a:srgbClr>
             </a:outerShdw>
           </a:effectLst>
@@ -3699,7 +3699,7 @@
             <a:r>
               <a:rPr lang="en-US" sz="1400" b="1" dirty="0">
                 <a:solidFill>
-                  <a:srgbClr val="EAF1FB"/>
+                  <a:srgbClr val="1E2A40"/>
                 </a:solidFill>
                 <a:latin typeface="Microsoft JhengHei" pitchFamily="34" charset="0"/>
                 <a:ea typeface="Microsoft JhengHei" pitchFamily="34" charset="-122"/>
@@ -3716,7 +3716,7 @@
             <a:r>
               <a:rPr lang="en-US" sz="1050" dirty="0">
                 <a:solidFill>
-                  <a:srgbClr val="93A1B8"/>
+                  <a:srgbClr val="6E7C93"/>
                 </a:solidFill>
                 <a:latin typeface="Microsoft JhengHei" pitchFamily="34" charset="0"/>
                 <a:ea typeface="Microsoft JhengHei" pitchFamily="34" charset="-122"/>
@@ -3745,18 +3745,18 @@
             </a:avLst>
           </a:prstGeom>
           <a:solidFill>
-            <a:srgbClr val="36A06A"/>
+            <a:srgbClr val="2E9460"/>
           </a:solidFill>
           <a:ln w="12700">
             <a:solidFill>
-              <a:srgbClr val="33415C"/>
+              <a:srgbClr val="D7E0EE"/>
             </a:solidFill>
             <a:prstDash val="solid"/>
           </a:ln>
           <a:effectLst>
-            <a:outerShdw sx="100000" sy="100000" kx="0" ky="0" algn="bl" rotWithShape="0" blurRad="114300" dist="38100" dir="5400000">
-              <a:srgbClr val="000000">
-                <a:alpha val="32000"/>
+            <a:outerShdw sx="100000" sy="100000" kx="0" ky="0" algn="bl" rotWithShape="0" blurRad="88900" dist="25400" dir="5400000">
+              <a:srgbClr val="8895AC">
+                <a:alpha val="28000"/>
               </a:srgbClr>
             </a:outerShdw>
           </a:effectLst>
@@ -3789,7 +3789,7 @@
             <a:r>
               <a:rPr lang="en-US" sz="1400" b="1" dirty="0">
                 <a:solidFill>
-                  <a:srgbClr val="0E1626"/>
+                  <a:srgbClr val="FFFFFF"/>
                 </a:solidFill>
                 <a:latin typeface="Microsoft JhengHei" pitchFamily="34" charset="0"/>
                 <a:ea typeface="Microsoft JhengHei" pitchFamily="34" charset="-122"/>
@@ -3806,7 +3806,7 @@
             <a:r>
               <a:rPr lang="en-US" sz="1050" dirty="0">
                 <a:solidFill>
-                  <a:srgbClr val="0E1626"/>
+                  <a:srgbClr val="F6F8FC"/>
                 </a:solidFill>
                 <a:latin typeface="Microsoft JhengHei" pitchFamily="34" charset="0"/>
                 <a:ea typeface="Microsoft JhengHei" pitchFamily="34" charset="-122"/>
@@ -3845,7 +3845,7 @@
             <a:r>
               <a:rPr lang="en-US" sz="1000" dirty="0">
                 <a:solidFill>
-                  <a:srgbClr val="38BDF8"/>
+                  <a:srgbClr val="0E9BD6"/>
                 </a:solidFill>
                 <a:latin typeface="Microsoft JhengHei" pitchFamily="34" charset="0"/>
                 <a:ea typeface="Microsoft JhengHei" pitchFamily="34" charset="-122"/>
@@ -3862,7 +3862,7 @@
             <a:r>
               <a:rPr lang="en-US" sz="1000" dirty="0">
                 <a:solidFill>
-                  <a:srgbClr val="38BDF8"/>
+                  <a:srgbClr val="0E9BD6"/>
                 </a:solidFill>
                 <a:latin typeface="Microsoft JhengHei" pitchFamily="34" charset="0"/>
                 <a:ea typeface="Microsoft JhengHei" pitchFamily="34" charset="-122"/>
@@ -3891,7 +3891,7 @@
           <a:noFill/>
           <a:ln w="25400">
             <a:solidFill>
-              <a:srgbClr val="38BDF8"/>
+              <a:srgbClr val="0E9BD6"/>
             </a:solidFill>
             <a:prstDash val="solid"/>
             <a:tailEnd type="triangle"/>
@@ -3925,7 +3925,7 @@
             <a:r>
               <a:rPr lang="en-US" sz="1200" dirty="0">
                 <a:solidFill>
-                  <a:srgbClr val="BCC8DA"/>
+                  <a:srgbClr val="44546D"/>
                 </a:solidFill>
                 <a:latin typeface="Microsoft JhengHei" pitchFamily="34" charset="0"/>
                 <a:ea typeface="Microsoft JhengHei" pitchFamily="34" charset="-122"/>
@@ -3954,18 +3954,18 @@
             </a:avLst>
           </a:prstGeom>
           <a:solidFill>
-            <a:srgbClr val="1B2436"/>
+            <a:srgbClr val="FFFFFF"/>
           </a:solidFill>
           <a:ln w="12700">
             <a:solidFill>
-              <a:srgbClr val="33415C"/>
+              <a:srgbClr val="D7E0EE"/>
             </a:solidFill>
             <a:prstDash val="solid"/>
           </a:ln>
           <a:effectLst>
-            <a:outerShdw sx="100000" sy="100000" kx="0" ky="0" algn="bl" rotWithShape="0" blurRad="114300" dist="38100" dir="5400000">
-              <a:srgbClr val="000000">
-                <a:alpha val="32000"/>
+            <a:outerShdw sx="100000" sy="100000" kx="0" ky="0" algn="bl" rotWithShape="0" blurRad="88900" dist="25400" dir="5400000">
+              <a:srgbClr val="8895AC">
+                <a:alpha val="28000"/>
               </a:srgbClr>
             </a:outerShdw>
           </a:effectLst>
@@ -3986,7 +3986,7 @@
             <a:avLst/>
           </a:prstGeom>
           <a:solidFill>
-            <a:srgbClr val="36A06A"/>
+            <a:srgbClr val="2E9460"/>
           </a:solidFill>
           <a:ln/>
         </p:spPr>
@@ -4018,7 +4018,7 @@
             <a:r>
               <a:rPr lang="en-US" sz="1500" b="1" dirty="0">
                 <a:solidFill>
-                  <a:srgbClr val="EAF1FB"/>
+                  <a:srgbClr val="1E2A40"/>
                 </a:solidFill>
                 <a:latin typeface="Microsoft JhengHei" pitchFamily="34" charset="0"/>
                 <a:ea typeface="Microsoft JhengHei" pitchFamily="34" charset="-122"/>
@@ -4057,7 +4057,7 @@
             <a:r>
               <a:rPr lang="en-US" sz="1250" b="1" dirty="0">
                 <a:solidFill>
-                  <a:srgbClr val="38BDF8"/>
+                  <a:srgbClr val="0E9BD6"/>
                 </a:solidFill>
                 <a:latin typeface="Microsoft JhengHei" pitchFamily="34" charset="0"/>
                 <a:ea typeface="Microsoft JhengHei" pitchFamily="34" charset="-122"/>
@@ -4096,7 +4096,7 @@
             <a:r>
               <a:rPr lang="en-US" sz="1250" dirty="0">
                 <a:solidFill>
-                  <a:srgbClr val="BCC8DA"/>
+                  <a:srgbClr val="44546D"/>
                 </a:solidFill>
                 <a:latin typeface="Microsoft JhengHei" pitchFamily="34" charset="0"/>
                 <a:ea typeface="Microsoft JhengHei" pitchFamily="34" charset="-122"/>
@@ -4135,7 +4135,7 @@
             <a:r>
               <a:rPr lang="en-US" sz="1250" b="1" dirty="0">
                 <a:solidFill>
-                  <a:srgbClr val="38BDF8"/>
+                  <a:srgbClr val="0E9BD6"/>
                 </a:solidFill>
                 <a:latin typeface="Microsoft JhengHei" pitchFamily="34" charset="0"/>
                 <a:ea typeface="Microsoft JhengHei" pitchFamily="34" charset="-122"/>
@@ -4174,7 +4174,7 @@
             <a:r>
               <a:rPr lang="en-US" sz="1250" dirty="0">
                 <a:solidFill>
-                  <a:srgbClr val="BCC8DA"/>
+                  <a:srgbClr val="44546D"/>
                 </a:solidFill>
                 <a:latin typeface="Microsoft JhengHei" pitchFamily="34" charset="0"/>
                 <a:ea typeface="Microsoft JhengHei" pitchFamily="34" charset="-122"/>
@@ -4213,7 +4213,7 @@
             <a:r>
               <a:rPr lang="en-US" sz="1250" b="1" dirty="0">
                 <a:solidFill>
-                  <a:srgbClr val="38BDF8"/>
+                  <a:srgbClr val="0E9BD6"/>
                 </a:solidFill>
                 <a:latin typeface="Microsoft JhengHei" pitchFamily="34" charset="0"/>
                 <a:ea typeface="Microsoft JhengHei" pitchFamily="34" charset="-122"/>
@@ -4252,7 +4252,7 @@
             <a:r>
               <a:rPr lang="en-US" sz="1250" dirty="0">
                 <a:solidFill>
-                  <a:srgbClr val="BCC8DA"/>
+                  <a:srgbClr val="44546D"/>
                 </a:solidFill>
                 <a:latin typeface="Microsoft JhengHei" pitchFamily="34" charset="0"/>
                 <a:ea typeface="Microsoft JhengHei" pitchFamily="34" charset="-122"/>
@@ -4291,7 +4291,7 @@
             <a:r>
               <a:rPr lang="en-US" sz="1250" b="1" dirty="0">
                 <a:solidFill>
-                  <a:srgbClr val="38BDF8"/>
+                  <a:srgbClr val="0E9BD6"/>
                 </a:solidFill>
                 <a:latin typeface="Microsoft JhengHei" pitchFamily="34" charset="0"/>
                 <a:ea typeface="Microsoft JhengHei" pitchFamily="34" charset="-122"/>
@@ -4330,7 +4330,7 @@
             <a:r>
               <a:rPr lang="en-US" sz="1250" dirty="0">
                 <a:solidFill>
-                  <a:srgbClr val="BCC8DA"/>
+                  <a:srgbClr val="44546D"/>
                 </a:solidFill>
                 <a:latin typeface="Microsoft JhengHei" pitchFamily="34" charset="0"/>
                 <a:ea typeface="Microsoft JhengHei" pitchFamily="34" charset="-122"/>
@@ -4369,7 +4369,7 @@
             <a:r>
               <a:rPr lang="en-US" sz="1250" b="1" dirty="0">
                 <a:solidFill>
-                  <a:srgbClr val="38BDF8"/>
+                  <a:srgbClr val="0E9BD6"/>
                 </a:solidFill>
                 <a:latin typeface="Microsoft JhengHei" pitchFamily="34" charset="0"/>
                 <a:ea typeface="Microsoft JhengHei" pitchFamily="34" charset="-122"/>
@@ -4408,7 +4408,7 @@
             <a:r>
               <a:rPr lang="en-US" sz="1250" dirty="0">
                 <a:solidFill>
-                  <a:srgbClr val="BCC8DA"/>
+                  <a:srgbClr val="44546D"/>
                 </a:solidFill>
                 <a:latin typeface="Microsoft JhengHei" pitchFamily="34" charset="0"/>
                 <a:ea typeface="Microsoft JhengHei" pitchFamily="34" charset="-122"/>
@@ -4437,18 +4437,18 @@
             </a:avLst>
           </a:prstGeom>
           <a:solidFill>
-            <a:srgbClr val="1B2436"/>
+            <a:srgbClr val="FFFFFF"/>
           </a:solidFill>
           <a:ln w="12700">
             <a:solidFill>
-              <a:srgbClr val="33415C"/>
+              <a:srgbClr val="D7E0EE"/>
             </a:solidFill>
             <a:prstDash val="solid"/>
           </a:ln>
           <a:effectLst>
-            <a:outerShdw sx="100000" sy="100000" kx="0" ky="0" algn="bl" rotWithShape="0" blurRad="114300" dist="38100" dir="5400000">
-              <a:srgbClr val="000000">
-                <a:alpha val="32000"/>
+            <a:outerShdw sx="100000" sy="100000" kx="0" ky="0" algn="bl" rotWithShape="0" blurRad="88900" dist="25400" dir="5400000">
+              <a:srgbClr val="8895AC">
+                <a:alpha val="28000"/>
               </a:srgbClr>
             </a:outerShdw>
           </a:effectLst>
@@ -4469,7 +4469,7 @@
             <a:avLst/>
           </a:prstGeom>
           <a:solidFill>
-            <a:srgbClr val="36A06A"/>
+            <a:srgbClr val="2E9460"/>
           </a:solidFill>
           <a:ln/>
         </p:spPr>
@@ -4501,7 +4501,7 @@
             <a:r>
               <a:rPr lang="en-US" sz="1500" b="1" dirty="0">
                 <a:solidFill>
-                  <a:srgbClr val="EAF1FB"/>
+                  <a:srgbClr val="1E2A40"/>
                 </a:solidFill>
                 <a:latin typeface="Microsoft JhengHei" pitchFamily="34" charset="0"/>
                 <a:ea typeface="Microsoft JhengHei" pitchFamily="34" charset="-122"/>
@@ -4544,7 +4544,7 @@
             <a:r>
               <a:rPr lang="en-US" sz="1250" dirty="0">
                 <a:solidFill>
-                  <a:srgbClr val="BCC8DA"/>
+                  <a:srgbClr val="44546D"/>
                 </a:solidFill>
                 <a:latin typeface="Microsoft JhengHei" pitchFamily="34" charset="0"/>
                 <a:ea typeface="Microsoft JhengHei" pitchFamily="34" charset="-122"/>
@@ -4565,7 +4565,7 @@
             <a:r>
               <a:rPr lang="en-US" sz="1250" dirty="0">
                 <a:solidFill>
-                  <a:srgbClr val="BCC8DA"/>
+                  <a:srgbClr val="44546D"/>
                 </a:solidFill>
                 <a:latin typeface="Microsoft JhengHei" pitchFamily="34" charset="0"/>
                 <a:ea typeface="Microsoft JhengHei" pitchFamily="34" charset="-122"/>
@@ -4594,18 +4594,18 @@
             </a:avLst>
           </a:prstGeom>
           <a:solidFill>
-            <a:srgbClr val="1B2436"/>
+            <a:srgbClr val="FFFFFF"/>
           </a:solidFill>
           <a:ln w="12700">
             <a:solidFill>
-              <a:srgbClr val="33415C"/>
+              <a:srgbClr val="D7E0EE"/>
             </a:solidFill>
             <a:prstDash val="solid"/>
           </a:ln>
           <a:effectLst>
-            <a:outerShdw sx="100000" sy="100000" kx="0" ky="0" algn="bl" rotWithShape="0" blurRad="114300" dist="38100" dir="5400000">
-              <a:srgbClr val="000000">
-                <a:alpha val="32000"/>
+            <a:outerShdw sx="100000" sy="100000" kx="0" ky="0" algn="bl" rotWithShape="0" blurRad="88900" dist="25400" dir="5400000">
+              <a:srgbClr val="8895AC">
+                <a:alpha val="28000"/>
               </a:srgbClr>
             </a:outerShdw>
           </a:effectLst>
@@ -4626,7 +4626,7 @@
             <a:avLst/>
           </a:prstGeom>
           <a:solidFill>
-            <a:srgbClr val="E8923E"/>
+            <a:srgbClr val="D9791C"/>
           </a:solidFill>
           <a:ln/>
         </p:spPr>
@@ -4658,7 +4658,7 @@
             <a:r>
               <a:rPr lang="en-US" sz="1500" b="1" dirty="0">
                 <a:solidFill>
-                  <a:srgbClr val="EAF1FB"/>
+                  <a:srgbClr val="1E2A40"/>
                 </a:solidFill>
                 <a:latin typeface="Microsoft JhengHei" pitchFamily="34" charset="0"/>
                 <a:ea typeface="Microsoft JhengHei" pitchFamily="34" charset="-122"/>
@@ -4701,7 +4701,7 @@
             <a:r>
               <a:rPr lang="en-US" sz="1250" dirty="0">
                 <a:solidFill>
-                  <a:srgbClr val="BCC8DA"/>
+                  <a:srgbClr val="44546D"/>
                 </a:solidFill>
                 <a:latin typeface="Microsoft JhengHei" pitchFamily="34" charset="0"/>
                 <a:ea typeface="Microsoft JhengHei" pitchFamily="34" charset="-122"/>
@@ -4722,7 +4722,7 @@
             <a:r>
               <a:rPr lang="en-US" sz="1250" dirty="0">
                 <a:solidFill>
-                  <a:srgbClr val="BCC8DA"/>
+                  <a:srgbClr val="44546D"/>
                 </a:solidFill>
                 <a:latin typeface="Microsoft JhengHei" pitchFamily="34" charset="0"/>
                 <a:ea typeface="Microsoft JhengHei" pitchFamily="34" charset="-122"/>
@@ -4751,7 +4751,7 @@
           <a:noFill/>
           <a:ln w="12700">
             <a:solidFill>
-              <a:srgbClr val="33415C"/>
+              <a:srgbClr val="D7E0EE"/>
             </a:solidFill>
             <a:prstDash val="solid"/>
           </a:ln>
@@ -4784,7 +4784,7 @@
             <a:r>
               <a:rPr lang="en-US" sz="900" dirty="0">
                 <a:solidFill>
-                  <a:srgbClr val="93A1B8"/>
+                  <a:srgbClr val="6E7C93"/>
                 </a:solidFill>
                 <a:latin typeface="Microsoft JhengHei" pitchFamily="34" charset="0"/>
                 <a:ea typeface="Microsoft JhengHei" pitchFamily="34" charset="-122"/>
@@ -4823,7 +4823,7 @@
             <a:r>
               <a:rPr lang="en-US" sz="900" dirty="0">
                 <a:solidFill>
-                  <a:srgbClr val="93A1B8"/>
+                  <a:srgbClr val="6E7C93"/>
                 </a:solidFill>
                 <a:latin typeface="Microsoft JhengHei" pitchFamily="34" charset="0"/>
                 <a:ea typeface="Microsoft JhengHei" pitchFamily="34" charset="-122"/>
@@ -4849,7 +4849,7 @@
     <p:bg>
       <p:bgPr>
         <a:solidFill>
-          <a:srgbClr val="0E1626"/>
+          <a:srgbClr val="F6F8FC"/>
         </a:solidFill>
       </p:bgPr>
     </p:bg>
@@ -4882,7 +4882,7 @@
             <a:avLst/>
           </a:prstGeom>
           <a:solidFill>
-            <a:srgbClr val="9A5BD0"/>
+            <a:srgbClr val="8348B8"/>
           </a:solidFill>
           <a:ln/>
         </p:spPr>
@@ -4902,13 +4902,13 @@
             <a:avLst/>
           </a:prstGeom>
           <a:solidFill>
-            <a:srgbClr val="9A5BD0"/>
+            <a:srgbClr val="8348B8"/>
           </a:solidFill>
           <a:ln/>
           <a:effectLst>
-            <a:outerShdw sx="100000" sy="100000" kx="0" ky="0" algn="bl" rotWithShape="0" blurRad="114300" dist="38100" dir="5400000">
-              <a:srgbClr val="000000">
-                <a:alpha val="32000"/>
+            <a:outerShdw sx="100000" sy="100000" kx="0" ky="0" algn="bl" rotWithShape="0" blurRad="88900" dist="25400" dir="5400000">
+              <a:srgbClr val="8895AC">
+                <a:alpha val="28000"/>
               </a:srgbClr>
             </a:outerShdw>
           </a:effectLst>
@@ -4941,7 +4941,7 @@
             <a:r>
               <a:rPr lang="en-US" sz="2600" b="1" dirty="0">
                 <a:solidFill>
-                  <a:srgbClr val="0E1626"/>
+                  <a:srgbClr val="FFFFFF"/>
                 </a:solidFill>
                 <a:latin typeface="Microsoft JhengHei" pitchFamily="34" charset="0"/>
                 <a:ea typeface="Microsoft JhengHei" pitchFamily="34" charset="-122"/>
@@ -4980,7 +4980,7 @@
             <a:r>
               <a:rPr lang="en-US" sz="1250" b="1" spc="300" kern="0" dirty="0">
                 <a:solidFill>
-                  <a:srgbClr val="9A5BD0"/>
+                  <a:srgbClr val="8348B8"/>
                 </a:solidFill>
                 <a:latin typeface="Microsoft JhengHei" pitchFamily="34" charset="0"/>
                 <a:ea typeface="Microsoft JhengHei" pitchFamily="34" charset="-122"/>
@@ -5019,7 +5019,7 @@
             <a:r>
               <a:rPr lang="en-US" sz="2900" b="1" dirty="0">
                 <a:solidFill>
-                  <a:srgbClr val="EAF1FB"/>
+                  <a:srgbClr val="1E2A40"/>
                 </a:solidFill>
                 <a:latin typeface="Microsoft JhengHei" pitchFamily="34" charset="0"/>
                 <a:ea typeface="Microsoft JhengHei" pitchFamily="34" charset="-122"/>
@@ -5058,7 +5058,7 @@
             <a:r>
               <a:rPr lang="en-US" sz="1300" dirty="0">
                 <a:solidFill>
-                  <a:srgbClr val="BCC8DA"/>
+                  <a:srgbClr val="44546D"/>
                 </a:solidFill>
                 <a:latin typeface="Microsoft JhengHei" pitchFamily="34" charset="0"/>
                 <a:ea typeface="Microsoft JhengHei" pitchFamily="34" charset="-122"/>
@@ -5087,18 +5087,18 @@
             </a:avLst>
           </a:prstGeom>
           <a:solidFill>
-            <a:srgbClr val="1B2436"/>
+            <a:srgbClr val="FFFFFF"/>
           </a:solidFill>
           <a:ln w="12700">
             <a:solidFill>
-              <a:srgbClr val="33415C"/>
+              <a:srgbClr val="D7E0EE"/>
             </a:solidFill>
             <a:prstDash val="solid"/>
           </a:ln>
           <a:effectLst>
-            <a:outerShdw sx="100000" sy="100000" kx="0" ky="0" algn="bl" rotWithShape="0" blurRad="114300" dist="38100" dir="5400000">
-              <a:srgbClr val="000000">
-                <a:alpha val="32000"/>
+            <a:outerShdw sx="100000" sy="100000" kx="0" ky="0" algn="bl" rotWithShape="0" blurRad="88900" dist="25400" dir="5400000">
+              <a:srgbClr val="8895AC">
+                <a:alpha val="28000"/>
               </a:srgbClr>
             </a:outerShdw>
           </a:effectLst>
@@ -5121,7 +5121,7 @@
             </a:avLst>
           </a:prstGeom>
           <a:solidFill>
-            <a:srgbClr val="E8923E"/>
+            <a:srgbClr val="D9791C"/>
           </a:solidFill>
           <a:ln/>
         </p:spPr>
@@ -5141,7 +5141,7 @@
             <a:avLst/>
           </a:prstGeom>
           <a:solidFill>
-            <a:srgbClr val="E8923E"/>
+            <a:srgbClr val="D9791C"/>
           </a:solidFill>
           <a:ln/>
         </p:spPr>
@@ -5173,7 +5173,7 @@
             <a:r>
               <a:rPr lang="en-US" sz="1700" b="1" dirty="0">
                 <a:solidFill>
-                  <a:srgbClr val="0E1626"/>
+                  <a:srgbClr val="FFFFFF"/>
                 </a:solidFill>
                 <a:latin typeface="Microsoft JhengHei" pitchFamily="34" charset="0"/>
                 <a:ea typeface="Microsoft JhengHei" pitchFamily="34" charset="-122"/>
@@ -5212,7 +5212,7 @@
             <a:r>
               <a:rPr lang="en-US" sz="1300" b="1" dirty="0">
                 <a:solidFill>
-                  <a:srgbClr val="E8923E"/>
+                  <a:srgbClr val="D9791C"/>
                 </a:solidFill>
                 <a:latin typeface="Microsoft JhengHei" pitchFamily="34" charset="0"/>
                 <a:ea typeface="Microsoft JhengHei" pitchFamily="34" charset="-122"/>
@@ -5251,7 +5251,7 @@
             <a:r>
               <a:rPr lang="en-US" sz="1200" dirty="0">
                 <a:solidFill>
-                  <a:srgbClr val="BCC8DA"/>
+                  <a:srgbClr val="44546D"/>
                 </a:solidFill>
                 <a:latin typeface="Microsoft JhengHei" pitchFamily="34" charset="0"/>
                 <a:ea typeface="Microsoft JhengHei" pitchFamily="34" charset="-122"/>
@@ -5268,7 +5268,7 @@
             <a:r>
               <a:rPr lang="en-US" sz="1200" dirty="0">
                 <a:solidFill>
-                  <a:srgbClr val="BCC8DA"/>
+                  <a:srgbClr val="44546D"/>
                 </a:solidFill>
                 <a:latin typeface="Microsoft JhengHei" pitchFamily="34" charset="0"/>
                 <a:ea typeface="Microsoft JhengHei" pitchFamily="34" charset="-122"/>
@@ -5297,18 +5297,18 @@
             </a:avLst>
           </a:prstGeom>
           <a:solidFill>
-            <a:srgbClr val="1B2436"/>
+            <a:srgbClr val="FFFFFF"/>
           </a:solidFill>
           <a:ln w="12700">
             <a:solidFill>
-              <a:srgbClr val="33415C"/>
+              <a:srgbClr val="D7E0EE"/>
             </a:solidFill>
             <a:prstDash val="solid"/>
           </a:ln>
           <a:effectLst>
-            <a:outerShdw sx="100000" sy="100000" kx="0" ky="0" algn="bl" rotWithShape="0" blurRad="114300" dist="38100" dir="5400000">
-              <a:srgbClr val="000000">
-                <a:alpha val="32000"/>
+            <a:outerShdw sx="100000" sy="100000" kx="0" ky="0" algn="bl" rotWithShape="0" blurRad="88900" dist="25400" dir="5400000">
+              <a:srgbClr val="8895AC">
+                <a:alpha val="28000"/>
               </a:srgbClr>
             </a:outerShdw>
           </a:effectLst>
@@ -5331,7 +5331,7 @@
             </a:avLst>
           </a:prstGeom>
           <a:solidFill>
-            <a:srgbClr val="4A86D4"/>
+            <a:srgbClr val="2F6FC0"/>
           </a:solidFill>
           <a:ln/>
         </p:spPr>
@@ -5351,7 +5351,7 @@
             <a:avLst/>
           </a:prstGeom>
           <a:solidFill>
-            <a:srgbClr val="4A86D4"/>
+            <a:srgbClr val="2F6FC0"/>
           </a:solidFill>
           <a:ln/>
         </p:spPr>
@@ -5383,7 +5383,7 @@
             <a:r>
               <a:rPr lang="en-US" sz="1700" b="1" dirty="0">
                 <a:solidFill>
-                  <a:srgbClr val="0E1626"/>
+                  <a:srgbClr val="FFFFFF"/>
                 </a:solidFill>
                 <a:latin typeface="Microsoft JhengHei" pitchFamily="34" charset="0"/>
                 <a:ea typeface="Microsoft JhengHei" pitchFamily="34" charset="-122"/>
@@ -5422,7 +5422,7 @@
             <a:r>
               <a:rPr lang="en-US" sz="1300" b="1" dirty="0">
                 <a:solidFill>
-                  <a:srgbClr val="4A86D4"/>
+                  <a:srgbClr val="2F6FC0"/>
                 </a:solidFill>
                 <a:latin typeface="Microsoft JhengHei" pitchFamily="34" charset="0"/>
                 <a:ea typeface="Microsoft JhengHei" pitchFamily="34" charset="-122"/>
@@ -5461,7 +5461,7 @@
             <a:r>
               <a:rPr lang="en-US" sz="1200" dirty="0">
                 <a:solidFill>
-                  <a:srgbClr val="BCC8DA"/>
+                  <a:srgbClr val="44546D"/>
                 </a:solidFill>
                 <a:latin typeface="Microsoft JhengHei" pitchFamily="34" charset="0"/>
                 <a:ea typeface="Microsoft JhengHei" pitchFamily="34" charset="-122"/>
@@ -5478,7 +5478,7 @@
             <a:r>
               <a:rPr lang="en-US" sz="1200" dirty="0">
                 <a:solidFill>
-                  <a:srgbClr val="BCC8DA"/>
+                  <a:srgbClr val="44546D"/>
                 </a:solidFill>
                 <a:latin typeface="Microsoft JhengHei" pitchFamily="34" charset="0"/>
                 <a:ea typeface="Microsoft JhengHei" pitchFamily="34" charset="-122"/>
@@ -5507,18 +5507,18 @@
             </a:avLst>
           </a:prstGeom>
           <a:solidFill>
-            <a:srgbClr val="1B2436"/>
+            <a:srgbClr val="FFFFFF"/>
           </a:solidFill>
           <a:ln w="12700">
             <a:solidFill>
-              <a:srgbClr val="33415C"/>
+              <a:srgbClr val="D7E0EE"/>
             </a:solidFill>
             <a:prstDash val="solid"/>
           </a:ln>
           <a:effectLst>
-            <a:outerShdw sx="100000" sy="100000" kx="0" ky="0" algn="bl" rotWithShape="0" blurRad="114300" dist="38100" dir="5400000">
-              <a:srgbClr val="000000">
-                <a:alpha val="32000"/>
+            <a:outerShdw sx="100000" sy="100000" kx="0" ky="0" algn="bl" rotWithShape="0" blurRad="88900" dist="25400" dir="5400000">
+              <a:srgbClr val="8895AC">
+                <a:alpha val="28000"/>
               </a:srgbClr>
             </a:outerShdw>
           </a:effectLst>
@@ -5541,7 +5541,7 @@
             </a:avLst>
           </a:prstGeom>
           <a:solidFill>
-            <a:srgbClr val="36A06A"/>
+            <a:srgbClr val="2E9460"/>
           </a:solidFill>
           <a:ln/>
         </p:spPr>
@@ -5561,7 +5561,7 @@
             <a:avLst/>
           </a:prstGeom>
           <a:solidFill>
-            <a:srgbClr val="36A06A"/>
+            <a:srgbClr val="2E9460"/>
           </a:solidFill>
           <a:ln/>
         </p:spPr>
@@ -5593,7 +5593,7 @@
             <a:r>
               <a:rPr lang="en-US" sz="1700" b="1" dirty="0">
                 <a:solidFill>
-                  <a:srgbClr val="0E1626"/>
+                  <a:srgbClr val="FFFFFF"/>
                 </a:solidFill>
                 <a:latin typeface="Microsoft JhengHei" pitchFamily="34" charset="0"/>
                 <a:ea typeface="Microsoft JhengHei" pitchFamily="34" charset="-122"/>
@@ -5632,7 +5632,7 @@
             <a:r>
               <a:rPr lang="en-US" sz="1300" b="1" dirty="0">
                 <a:solidFill>
-                  <a:srgbClr val="36A06A"/>
+                  <a:srgbClr val="2E9460"/>
                 </a:solidFill>
                 <a:latin typeface="Microsoft JhengHei" pitchFamily="34" charset="0"/>
                 <a:ea typeface="Microsoft JhengHei" pitchFamily="34" charset="-122"/>
@@ -5671,7 +5671,7 @@
             <a:r>
               <a:rPr lang="en-US" sz="1200" dirty="0">
                 <a:solidFill>
-                  <a:srgbClr val="BCC8DA"/>
+                  <a:srgbClr val="44546D"/>
                 </a:solidFill>
                 <a:latin typeface="Microsoft JhengHei" pitchFamily="34" charset="0"/>
                 <a:ea typeface="Microsoft JhengHei" pitchFamily="34" charset="-122"/>
@@ -5688,7 +5688,7 @@
             <a:r>
               <a:rPr lang="en-US" sz="1200" dirty="0">
                 <a:solidFill>
-                  <a:srgbClr val="BCC8DA"/>
+                  <a:srgbClr val="44546D"/>
                 </a:solidFill>
                 <a:latin typeface="Microsoft JhengHei" pitchFamily="34" charset="0"/>
                 <a:ea typeface="Microsoft JhengHei" pitchFamily="34" charset="-122"/>
@@ -5717,18 +5717,18 @@
             </a:avLst>
           </a:prstGeom>
           <a:solidFill>
-            <a:srgbClr val="1B2436"/>
+            <a:srgbClr val="FFFFFF"/>
           </a:solidFill>
           <a:ln w="12700">
             <a:solidFill>
-              <a:srgbClr val="33415C"/>
+              <a:srgbClr val="D7E0EE"/>
             </a:solidFill>
             <a:prstDash val="solid"/>
           </a:ln>
           <a:effectLst>
-            <a:outerShdw sx="100000" sy="100000" kx="0" ky="0" algn="bl" rotWithShape="0" blurRad="114300" dist="38100" dir="5400000">
-              <a:srgbClr val="000000">
-                <a:alpha val="32000"/>
+            <a:outerShdw sx="100000" sy="100000" kx="0" ky="0" algn="bl" rotWithShape="0" blurRad="88900" dist="25400" dir="5400000">
+              <a:srgbClr val="8895AC">
+                <a:alpha val="28000"/>
               </a:srgbClr>
             </a:outerShdw>
           </a:effectLst>
@@ -5751,7 +5751,7 @@
             </a:avLst>
           </a:prstGeom>
           <a:solidFill>
-            <a:srgbClr val="9A5BD0"/>
+            <a:srgbClr val="8348B8"/>
           </a:solidFill>
           <a:ln/>
         </p:spPr>
@@ -5771,7 +5771,7 @@
             <a:avLst/>
           </a:prstGeom>
           <a:solidFill>
-            <a:srgbClr val="9A5BD0"/>
+            <a:srgbClr val="8348B8"/>
           </a:solidFill>
           <a:ln/>
         </p:spPr>
@@ -5803,7 +5803,7 @@
             <a:r>
               <a:rPr lang="en-US" sz="1700" b="1" dirty="0">
                 <a:solidFill>
-                  <a:srgbClr val="0E1626"/>
+                  <a:srgbClr val="FFFFFF"/>
                 </a:solidFill>
                 <a:latin typeface="Microsoft JhengHei" pitchFamily="34" charset="0"/>
                 <a:ea typeface="Microsoft JhengHei" pitchFamily="34" charset="-122"/>
@@ -5842,7 +5842,7 @@
             <a:r>
               <a:rPr lang="en-US" sz="1300" b="1" dirty="0">
                 <a:solidFill>
-                  <a:srgbClr val="9A5BD0"/>
+                  <a:srgbClr val="8348B8"/>
                 </a:solidFill>
                 <a:latin typeface="Microsoft JhengHei" pitchFamily="34" charset="0"/>
                 <a:ea typeface="Microsoft JhengHei" pitchFamily="34" charset="-122"/>
@@ -5881,7 +5881,7 @@
             <a:r>
               <a:rPr lang="en-US" sz="1200" dirty="0">
                 <a:solidFill>
-                  <a:srgbClr val="BCC8DA"/>
+                  <a:srgbClr val="44546D"/>
                 </a:solidFill>
                 <a:latin typeface="Microsoft JhengHei" pitchFamily="34" charset="0"/>
                 <a:ea typeface="Microsoft JhengHei" pitchFamily="34" charset="-122"/>
@@ -5898,7 +5898,7 @@
             <a:r>
               <a:rPr lang="en-US" sz="1200" dirty="0">
                 <a:solidFill>
-                  <a:srgbClr val="BCC8DA"/>
+                  <a:srgbClr val="44546D"/>
                 </a:solidFill>
                 <a:latin typeface="Microsoft JhengHei" pitchFamily="34" charset="0"/>
                 <a:ea typeface="Microsoft JhengHei" pitchFamily="34" charset="-122"/>
@@ -5927,18 +5927,18 @@
             </a:avLst>
           </a:prstGeom>
           <a:solidFill>
-            <a:srgbClr val="232E44"/>
+            <a:srgbClr val="EDF3FB"/>
           </a:solidFill>
           <a:ln w="12700">
             <a:solidFill>
-              <a:srgbClr val="33415C"/>
+              <a:srgbClr val="D7E0EE"/>
             </a:solidFill>
             <a:prstDash val="solid"/>
           </a:ln>
           <a:effectLst>
-            <a:outerShdw sx="100000" sy="100000" kx="0" ky="0" algn="bl" rotWithShape="0" blurRad="114300" dist="38100" dir="5400000">
-              <a:srgbClr val="000000">
-                <a:alpha val="32000"/>
+            <a:outerShdw sx="100000" sy="100000" kx="0" ky="0" algn="bl" rotWithShape="0" blurRad="88900" dist="25400" dir="5400000">
+              <a:srgbClr val="8895AC">
+                <a:alpha val="28000"/>
               </a:srgbClr>
             </a:outerShdw>
           </a:effectLst>
@@ -5959,7 +5959,7 @@
             <a:avLst/>
           </a:prstGeom>
           <a:solidFill>
-            <a:srgbClr val="38BDF8"/>
+            <a:srgbClr val="0E9BD6"/>
           </a:solidFill>
           <a:ln/>
         </p:spPr>
@@ -5991,7 +5991,7 @@
             <a:r>
               <a:rPr lang="en-US" sz="1500" b="1" dirty="0">
                 <a:solidFill>
-                  <a:srgbClr val="EAF1FB"/>
+                  <a:srgbClr val="1E2A40"/>
                 </a:solidFill>
                 <a:latin typeface="Microsoft JhengHei" pitchFamily="34" charset="0"/>
                 <a:ea typeface="Microsoft JhengHei" pitchFamily="34" charset="-122"/>
@@ -6033,7 +6033,7 @@
             <a:r>
               <a:rPr lang="en-US" sz="1300" dirty="0">
                 <a:solidFill>
-                  <a:srgbClr val="BCC8DA"/>
+                  <a:srgbClr val="44546D"/>
                 </a:solidFill>
                 <a:latin typeface="Microsoft JhengHei" pitchFamily="34" charset="0"/>
                 <a:ea typeface="Microsoft JhengHei" pitchFamily="34" charset="-122"/>
@@ -6053,7 +6053,7 @@
             <a:r>
               <a:rPr lang="en-US" sz="1300" dirty="0">
                 <a:solidFill>
-                  <a:srgbClr val="93A1B8"/>
+                  <a:srgbClr val="6E7C93"/>
                 </a:solidFill>
                 <a:latin typeface="Microsoft JhengHei" pitchFamily="34" charset="0"/>
                 <a:ea typeface="Microsoft JhengHei" pitchFamily="34" charset="-122"/>
@@ -6082,7 +6082,7 @@
           <a:noFill/>
           <a:ln w="12700">
             <a:solidFill>
-              <a:srgbClr val="33415C"/>
+              <a:srgbClr val="D7E0EE"/>
             </a:solidFill>
             <a:prstDash val="solid"/>
           </a:ln>
@@ -6115,7 +6115,7 @@
             <a:r>
               <a:rPr lang="en-US" sz="900" dirty="0">
                 <a:solidFill>
-                  <a:srgbClr val="93A1B8"/>
+                  <a:srgbClr val="6E7C93"/>
                 </a:solidFill>
                 <a:latin typeface="Microsoft JhengHei" pitchFamily="34" charset="0"/>
                 <a:ea typeface="Microsoft JhengHei" pitchFamily="34" charset="-122"/>
@@ -6154,7 +6154,7 @@
             <a:r>
               <a:rPr lang="en-US" sz="900" dirty="0">
                 <a:solidFill>
-                  <a:srgbClr val="93A1B8"/>
+                  <a:srgbClr val="6E7C93"/>
                 </a:solidFill>
                 <a:latin typeface="Microsoft JhengHei" pitchFamily="34" charset="0"/>
                 <a:ea typeface="Microsoft JhengHei" pitchFamily="34" charset="-122"/>
@@ -6180,7 +6180,7 @@
     <p:bg>
       <p:bgPr>
         <a:solidFill>
-          <a:srgbClr val="0E1626"/>
+          <a:srgbClr val="F6F8FC"/>
         </a:solidFill>
       </p:bgPr>
     </p:bg>
@@ -6213,7 +6213,7 @@
             <a:avLst/>
           </a:prstGeom>
           <a:solidFill>
-            <a:srgbClr val="38BDF8"/>
+            <a:srgbClr val="0E9BD6"/>
           </a:solidFill>
           <a:ln/>
         </p:spPr>
@@ -6233,13 +6233,13 @@
             <a:avLst/>
           </a:prstGeom>
           <a:solidFill>
-            <a:srgbClr val="38BDF8"/>
+            <a:srgbClr val="0E9BD6"/>
           </a:solidFill>
           <a:ln/>
           <a:effectLst>
-            <a:outerShdw sx="100000" sy="100000" kx="0" ky="0" algn="bl" rotWithShape="0" blurRad="114300" dist="38100" dir="5400000">
-              <a:srgbClr val="000000">
-                <a:alpha val="32000"/>
+            <a:outerShdw sx="100000" sy="100000" kx="0" ky="0" algn="bl" rotWithShape="0" blurRad="88900" dist="25400" dir="5400000">
+              <a:srgbClr val="8895AC">
+                <a:alpha val="28000"/>
               </a:srgbClr>
             </a:outerShdw>
           </a:effectLst>
@@ -6272,7 +6272,7 @@
             <a:r>
               <a:rPr lang="en-US" sz="1250" b="1" spc="300" kern="0" dirty="0">
                 <a:solidFill>
-                  <a:srgbClr val="38BDF8"/>
+                  <a:srgbClr val="0E9BD6"/>
                 </a:solidFill>
                 <a:latin typeface="Microsoft JhengHei" pitchFamily="34" charset="0"/>
                 <a:ea typeface="Microsoft JhengHei" pitchFamily="34" charset="-122"/>
@@ -6311,7 +6311,7 @@
             <a:r>
               <a:rPr lang="en-US" sz="2900" b="1" dirty="0">
                 <a:solidFill>
-                  <a:srgbClr val="EAF1FB"/>
+                  <a:srgbClr val="1E2A40"/>
                 </a:solidFill>
                 <a:latin typeface="Microsoft JhengHei" pitchFamily="34" charset="0"/>
                 <a:ea typeface="Microsoft JhengHei" pitchFamily="34" charset="-122"/>
@@ -6340,18 +6340,18 @@
             </a:avLst>
           </a:prstGeom>
           <a:solidFill>
-            <a:srgbClr val="1B2436"/>
+            <a:srgbClr val="FFFFFF"/>
           </a:solidFill>
           <a:ln w="12700">
             <a:solidFill>
-              <a:srgbClr val="33415C"/>
+              <a:srgbClr val="D7E0EE"/>
             </a:solidFill>
             <a:prstDash val="solid"/>
           </a:ln>
           <a:effectLst>
-            <a:outerShdw sx="100000" sy="100000" kx="0" ky="0" algn="bl" rotWithShape="0" blurRad="114300" dist="38100" dir="5400000">
-              <a:srgbClr val="000000">
-                <a:alpha val="32000"/>
+            <a:outerShdw sx="100000" sy="100000" kx="0" ky="0" algn="bl" rotWithShape="0" blurRad="88900" dist="25400" dir="5400000">
+              <a:srgbClr val="8895AC">
+                <a:alpha val="28000"/>
               </a:srgbClr>
             </a:outerShdw>
           </a:effectLst>
@@ -6384,7 +6384,7 @@
             <a:r>
               <a:rPr lang="en-US" sz="4600" b="1" dirty="0">
                 <a:solidFill>
-                  <a:srgbClr val="38BDF8"/>
+                  <a:srgbClr val="0E9BD6"/>
                 </a:solidFill>
                 <a:latin typeface="Microsoft JhengHei" pitchFamily="34" charset="0"/>
                 <a:ea typeface="Microsoft JhengHei" pitchFamily="34" charset="-122"/>
@@ -6398,7 +6398,7 @@
             <a:r>
               <a:rPr lang="en-US" sz="1600" b="1" dirty="0">
                 <a:solidFill>
-                  <a:srgbClr val="38BDF8"/>
+                  <a:srgbClr val="0E9BD6"/>
                 </a:solidFill>
                 <a:latin typeface="Microsoft JhengHei" pitchFamily="34" charset="0"/>
                 <a:ea typeface="Microsoft JhengHei" pitchFamily="34" charset="-122"/>
@@ -6437,7 +6437,7 @@
             <a:r>
               <a:rPr lang="en-US" sz="1200" dirty="0">
                 <a:solidFill>
-                  <a:srgbClr val="BCC8DA"/>
+                  <a:srgbClr val="44546D"/>
                 </a:solidFill>
                 <a:latin typeface="Microsoft JhengHei" pitchFamily="34" charset="0"/>
                 <a:ea typeface="Microsoft JhengHei" pitchFamily="34" charset="-122"/>
@@ -6466,18 +6466,18 @@
             </a:avLst>
           </a:prstGeom>
           <a:solidFill>
-            <a:srgbClr val="1B2436"/>
+            <a:srgbClr val="FFFFFF"/>
           </a:solidFill>
           <a:ln w="12700">
             <a:solidFill>
-              <a:srgbClr val="33415C"/>
+              <a:srgbClr val="D7E0EE"/>
             </a:solidFill>
             <a:prstDash val="solid"/>
           </a:ln>
           <a:effectLst>
-            <a:outerShdw sx="100000" sy="100000" kx="0" ky="0" algn="bl" rotWithShape="0" blurRad="114300" dist="38100" dir="5400000">
-              <a:srgbClr val="000000">
-                <a:alpha val="32000"/>
+            <a:outerShdw sx="100000" sy="100000" kx="0" ky="0" algn="bl" rotWithShape="0" blurRad="88900" dist="25400" dir="5400000">
+              <a:srgbClr val="8895AC">
+                <a:alpha val="28000"/>
               </a:srgbClr>
             </a:outerShdw>
           </a:effectLst>
@@ -6510,7 +6510,7 @@
             <a:r>
               <a:rPr lang="en-US" sz="4600" b="1" dirty="0">
                 <a:solidFill>
-                  <a:srgbClr val="E8923E"/>
+                  <a:srgbClr val="D9791C"/>
                 </a:solidFill>
                 <a:latin typeface="Microsoft JhengHei" pitchFamily="34" charset="0"/>
                 <a:ea typeface="Microsoft JhengHei" pitchFamily="34" charset="-122"/>
@@ -6524,7 +6524,7 @@
             <a:r>
               <a:rPr lang="en-US" sz="1600" b="1" dirty="0">
                 <a:solidFill>
-                  <a:srgbClr val="E8923E"/>
+                  <a:srgbClr val="D9791C"/>
                 </a:solidFill>
                 <a:latin typeface="Microsoft JhengHei" pitchFamily="34" charset="0"/>
                 <a:ea typeface="Microsoft JhengHei" pitchFamily="34" charset="-122"/>
@@ -6563,7 +6563,7 @@
             <a:r>
               <a:rPr lang="en-US" sz="1200" dirty="0">
                 <a:solidFill>
-                  <a:srgbClr val="BCC8DA"/>
+                  <a:srgbClr val="44546D"/>
                 </a:solidFill>
                 <a:latin typeface="Microsoft JhengHei" pitchFamily="34" charset="0"/>
                 <a:ea typeface="Microsoft JhengHei" pitchFamily="34" charset="-122"/>
@@ -6592,18 +6592,18 @@
             </a:avLst>
           </a:prstGeom>
           <a:solidFill>
-            <a:srgbClr val="1B2436"/>
+            <a:srgbClr val="FFFFFF"/>
           </a:solidFill>
           <a:ln w="12700">
             <a:solidFill>
-              <a:srgbClr val="33415C"/>
+              <a:srgbClr val="D7E0EE"/>
             </a:solidFill>
             <a:prstDash val="solid"/>
           </a:ln>
           <a:effectLst>
-            <a:outerShdw sx="100000" sy="100000" kx="0" ky="0" algn="bl" rotWithShape="0" blurRad="114300" dist="38100" dir="5400000">
-              <a:srgbClr val="000000">
-                <a:alpha val="32000"/>
+            <a:outerShdw sx="100000" sy="100000" kx="0" ky="0" algn="bl" rotWithShape="0" blurRad="88900" dist="25400" dir="5400000">
+              <a:srgbClr val="8895AC">
+                <a:alpha val="28000"/>
               </a:srgbClr>
             </a:outerShdw>
           </a:effectLst>
@@ -6636,7 +6636,7 @@
             <a:r>
               <a:rPr lang="en-US" sz="4600" b="1" dirty="0">
                 <a:solidFill>
-                  <a:srgbClr val="36A06A"/>
+                  <a:srgbClr val="2E9460"/>
                 </a:solidFill>
                 <a:latin typeface="Microsoft JhengHei" pitchFamily="34" charset="0"/>
                 <a:ea typeface="Microsoft JhengHei" pitchFamily="34" charset="-122"/>
@@ -6650,7 +6650,7 @@
             <a:r>
               <a:rPr lang="en-US" sz="1600" b="1" dirty="0">
                 <a:solidFill>
-                  <a:srgbClr val="36A06A"/>
+                  <a:srgbClr val="2E9460"/>
                 </a:solidFill>
                 <a:latin typeface="Microsoft JhengHei" pitchFamily="34" charset="0"/>
                 <a:ea typeface="Microsoft JhengHei" pitchFamily="34" charset="-122"/>
@@ -6689,7 +6689,7 @@
             <a:r>
               <a:rPr lang="en-US" sz="1200" dirty="0">
                 <a:solidFill>
-                  <a:srgbClr val="BCC8DA"/>
+                  <a:srgbClr val="44546D"/>
                 </a:solidFill>
                 <a:latin typeface="Microsoft JhengHei" pitchFamily="34" charset="0"/>
                 <a:ea typeface="Microsoft JhengHei" pitchFamily="34" charset="-122"/>
@@ -6718,18 +6718,18 @@
             </a:avLst>
           </a:prstGeom>
           <a:solidFill>
-            <a:srgbClr val="1B2436"/>
+            <a:srgbClr val="FFFFFF"/>
           </a:solidFill>
           <a:ln w="12700">
             <a:solidFill>
-              <a:srgbClr val="33415C"/>
+              <a:srgbClr val="D7E0EE"/>
             </a:solidFill>
             <a:prstDash val="solid"/>
           </a:ln>
           <a:effectLst>
-            <a:outerShdw sx="100000" sy="100000" kx="0" ky="0" algn="bl" rotWithShape="0" blurRad="114300" dist="38100" dir="5400000">
-              <a:srgbClr val="000000">
-                <a:alpha val="32000"/>
+            <a:outerShdw sx="100000" sy="100000" kx="0" ky="0" algn="bl" rotWithShape="0" blurRad="88900" dist="25400" dir="5400000">
+              <a:srgbClr val="8895AC">
+                <a:alpha val="28000"/>
               </a:srgbClr>
             </a:outerShdw>
           </a:effectLst>
@@ -6750,7 +6750,7 @@
             <a:avLst/>
           </a:prstGeom>
           <a:solidFill>
-            <a:srgbClr val="38BDF8"/>
+            <a:srgbClr val="0E9BD6"/>
           </a:solidFill>
           <a:ln/>
         </p:spPr>
@@ -6782,7 +6782,7 @@
             <a:r>
               <a:rPr lang="en-US" sz="1500" b="1" dirty="0">
                 <a:solidFill>
-                  <a:srgbClr val="EAF1FB"/>
+                  <a:srgbClr val="1E2A40"/>
                 </a:solidFill>
                 <a:latin typeface="Microsoft JhengHei" pitchFamily="34" charset="0"/>
                 <a:ea typeface="Microsoft JhengHei" pitchFamily="34" charset="-122"/>
@@ -6827,18 +6827,18 @@
             </a:avLst>
           </a:prstGeom>
           <a:solidFill>
-            <a:srgbClr val="232E44"/>
+            <a:srgbClr val="EDF3FB"/>
           </a:solidFill>
           <a:ln w="12700">
             <a:solidFill>
-              <a:srgbClr val="33415C"/>
+              <a:srgbClr val="D7E0EE"/>
             </a:solidFill>
             <a:prstDash val="solid"/>
           </a:ln>
           <a:effectLst>
-            <a:outerShdw sx="100000" sy="100000" kx="0" ky="0" algn="bl" rotWithShape="0" blurRad="114300" dist="38100" dir="5400000">
-              <a:srgbClr val="000000">
-                <a:alpha val="32000"/>
+            <a:outerShdw sx="100000" sy="100000" kx="0" ky="0" algn="bl" rotWithShape="0" blurRad="88900" dist="25400" dir="5400000">
+              <a:srgbClr val="8895AC">
+                <a:alpha val="28000"/>
               </a:srgbClr>
             </a:outerShdw>
           </a:effectLst>
@@ -6859,7 +6859,7 @@
             <a:avLst/>
           </a:prstGeom>
           <a:solidFill>
-            <a:srgbClr val="E8923E"/>
+            <a:srgbClr val="D9791C"/>
           </a:solidFill>
           <a:ln/>
         </p:spPr>
@@ -6891,7 +6891,7 @@
             <a:r>
               <a:rPr lang="en-US" sz="1500" b="1" dirty="0">
                 <a:solidFill>
-                  <a:srgbClr val="EAF1FB"/>
+                  <a:srgbClr val="1E2A40"/>
                 </a:solidFill>
                 <a:latin typeface="Microsoft JhengHei" pitchFamily="34" charset="0"/>
                 <a:ea typeface="Microsoft JhengHei" pitchFamily="34" charset="-122"/>
@@ -6934,7 +6934,7 @@
             <a:r>
               <a:rPr lang="en-US" sz="1250" dirty="0">
                 <a:solidFill>
-                  <a:srgbClr val="BCC8DA"/>
+                  <a:srgbClr val="44546D"/>
                 </a:solidFill>
                 <a:latin typeface="Microsoft JhengHei" pitchFamily="34" charset="0"/>
                 <a:ea typeface="Microsoft JhengHei" pitchFamily="34" charset="-122"/>
@@ -6955,7 +6955,7 @@
             <a:r>
               <a:rPr lang="en-US" sz="1250" dirty="0">
                 <a:solidFill>
-                  <a:srgbClr val="BCC8DA"/>
+                  <a:srgbClr val="44546D"/>
                 </a:solidFill>
                 <a:latin typeface="Microsoft JhengHei" pitchFamily="34" charset="0"/>
                 <a:ea typeface="Microsoft JhengHei" pitchFamily="34" charset="-122"/>
@@ -6976,7 +6976,7 @@
             <a:r>
               <a:rPr lang="en-US" sz="1250" dirty="0">
                 <a:solidFill>
-                  <a:srgbClr val="BCC8DA"/>
+                  <a:srgbClr val="44546D"/>
                 </a:solidFill>
                 <a:latin typeface="Microsoft JhengHei" pitchFamily="34" charset="0"/>
                 <a:ea typeface="Microsoft JhengHei" pitchFamily="34" charset="-122"/>
@@ -7005,7 +7005,7 @@
           <a:noFill/>
           <a:ln w="12700">
             <a:solidFill>
-              <a:srgbClr val="33415C"/>
+              <a:srgbClr val="D7E0EE"/>
             </a:solidFill>
             <a:prstDash val="solid"/>
           </a:ln>
@@ -7038,7 +7038,7 @@
             <a:r>
               <a:rPr lang="en-US" sz="900" dirty="0">
                 <a:solidFill>
-                  <a:srgbClr val="93A1B8"/>
+                  <a:srgbClr val="6E7C93"/>
                 </a:solidFill>
                 <a:latin typeface="Microsoft JhengHei" pitchFamily="34" charset="0"/>
                 <a:ea typeface="Microsoft JhengHei" pitchFamily="34" charset="-122"/>
@@ -7077,7 +7077,7 @@
             <a:r>
               <a:rPr lang="en-US" sz="900" dirty="0">
                 <a:solidFill>
-                  <a:srgbClr val="93A1B8"/>
+                  <a:srgbClr val="6E7C93"/>
                 </a:solidFill>
                 <a:latin typeface="Microsoft JhengHei" pitchFamily="34" charset="0"/>
                 <a:ea typeface="Microsoft JhengHei" pitchFamily="34" charset="-122"/>
@@ -7103,7 +7103,7 @@
     <p:bg>
       <p:bgPr>
         <a:solidFill>
-          <a:srgbClr val="0E1626"/>
+          <a:srgbClr val="F6F8FC"/>
         </a:solidFill>
       </p:bgPr>
     </p:bg>
@@ -7136,7 +7136,7 @@
             <a:avLst/>
           </a:prstGeom>
           <a:solidFill>
-            <a:srgbClr val="E8923E"/>
+            <a:srgbClr val="D9791C"/>
           </a:solidFill>
           <a:ln/>
         </p:spPr>
@@ -7156,13 +7156,13 @@
             <a:avLst/>
           </a:prstGeom>
           <a:solidFill>
-            <a:srgbClr val="E8923E"/>
+            <a:srgbClr val="D9791C"/>
           </a:solidFill>
           <a:ln/>
           <a:effectLst>
-            <a:outerShdw sx="100000" sy="100000" kx="0" ky="0" algn="bl" rotWithShape="0" blurRad="114300" dist="38100" dir="5400000">
-              <a:srgbClr val="000000">
-                <a:alpha val="32000"/>
+            <a:outerShdw sx="100000" sy="100000" kx="0" ky="0" algn="bl" rotWithShape="0" blurRad="88900" dist="25400" dir="5400000">
+              <a:srgbClr val="8895AC">
+                <a:alpha val="28000"/>
               </a:srgbClr>
             </a:outerShdw>
           </a:effectLst>
@@ -7195,7 +7195,7 @@
             <a:r>
               <a:rPr lang="en-US" sz="1250" b="1" spc="300" kern="0" dirty="0">
                 <a:solidFill>
-                  <a:srgbClr val="E8923E"/>
+                  <a:srgbClr val="D9791C"/>
                 </a:solidFill>
                 <a:latin typeface="Microsoft JhengHei" pitchFamily="34" charset="0"/>
                 <a:ea typeface="Microsoft JhengHei" pitchFamily="34" charset="-122"/>
@@ -7234,7 +7234,7 @@
             <a:r>
               <a:rPr lang="en-US" sz="2900" b="1" dirty="0">
                 <a:solidFill>
-                  <a:srgbClr val="EAF1FB"/>
+                  <a:srgbClr val="1E2A40"/>
                 </a:solidFill>
                 <a:latin typeface="Microsoft JhengHei" pitchFamily="34" charset="0"/>
                 <a:ea typeface="Microsoft JhengHei" pitchFamily="34" charset="-122"/>
@@ -7273,7 +7273,7 @@
             <a:r>
               <a:rPr lang="en-US" sz="1300" dirty="0">
                 <a:solidFill>
-                  <a:srgbClr val="BCC8DA"/>
+                  <a:srgbClr val="44546D"/>
                 </a:solidFill>
                 <a:latin typeface="Microsoft JhengHei" pitchFamily="34" charset="0"/>
                 <a:ea typeface="Microsoft JhengHei" pitchFamily="34" charset="-122"/>
@@ -7302,18 +7302,18 @@
             </a:avLst>
           </a:prstGeom>
           <a:solidFill>
-            <a:srgbClr val="1B2436"/>
+            <a:srgbClr val="FFFFFF"/>
           </a:solidFill>
           <a:ln w="12700">
             <a:solidFill>
-              <a:srgbClr val="33415C"/>
+              <a:srgbClr val="D7E0EE"/>
             </a:solidFill>
             <a:prstDash val="solid"/>
           </a:ln>
           <a:effectLst>
-            <a:outerShdw sx="100000" sy="100000" kx="0" ky="0" algn="bl" rotWithShape="0" blurRad="114300" dist="38100" dir="5400000">
-              <a:srgbClr val="000000">
-                <a:alpha val="32000"/>
+            <a:outerShdw sx="100000" sy="100000" kx="0" ky="0" algn="bl" rotWithShape="0" blurRad="88900" dist="25400" dir="5400000">
+              <a:srgbClr val="8895AC">
+                <a:alpha val="28000"/>
               </a:srgbClr>
             </a:outerShdw>
           </a:effectLst>
@@ -7334,7 +7334,7 @@
             <a:avLst/>
           </a:prstGeom>
           <a:solidFill>
-            <a:srgbClr val="38BDF8"/>
+            <a:srgbClr val="0E9BD6"/>
           </a:solidFill>
           <a:ln/>
         </p:spPr>
@@ -7366,7 +7366,7 @@
             <a:r>
               <a:rPr lang="en-US" sz="1600" b="1" dirty="0">
                 <a:solidFill>
-                  <a:srgbClr val="EAF1FB"/>
+                  <a:srgbClr val="1E2A40"/>
                 </a:solidFill>
                 <a:latin typeface="Microsoft JhengHei" pitchFamily="34" charset="0"/>
                 <a:ea typeface="Microsoft JhengHei" pitchFamily="34" charset="-122"/>
@@ -7405,7 +7405,7 @@
             <a:r>
               <a:rPr lang="en-US" sz="1250" dirty="0">
                 <a:solidFill>
-                  <a:srgbClr val="BCC8DA"/>
+                  <a:srgbClr val="44546D"/>
                 </a:solidFill>
                 <a:latin typeface="Microsoft JhengHei" pitchFamily="34" charset="0"/>
                 <a:ea typeface="Microsoft JhengHei" pitchFamily="34" charset="-122"/>
@@ -7434,18 +7434,18 @@
             </a:avLst>
           </a:prstGeom>
           <a:solidFill>
-            <a:srgbClr val="1B2436"/>
+            <a:srgbClr val="FFFFFF"/>
           </a:solidFill>
           <a:ln w="12700">
             <a:solidFill>
-              <a:srgbClr val="33415C"/>
+              <a:srgbClr val="D7E0EE"/>
             </a:solidFill>
             <a:prstDash val="solid"/>
           </a:ln>
           <a:effectLst>
-            <a:outerShdw sx="100000" sy="100000" kx="0" ky="0" algn="bl" rotWithShape="0" blurRad="114300" dist="38100" dir="5400000">
-              <a:srgbClr val="000000">
-                <a:alpha val="32000"/>
+            <a:outerShdw sx="100000" sy="100000" kx="0" ky="0" algn="bl" rotWithShape="0" blurRad="88900" dist="25400" dir="5400000">
+              <a:srgbClr val="8895AC">
+                <a:alpha val="28000"/>
               </a:srgbClr>
             </a:outerShdw>
           </a:effectLst>
@@ -7466,7 +7466,7 @@
             <a:avLst/>
           </a:prstGeom>
           <a:solidFill>
-            <a:srgbClr val="E8923E"/>
+            <a:srgbClr val="D9791C"/>
           </a:solidFill>
           <a:ln/>
         </p:spPr>
@@ -7498,7 +7498,7 @@
             <a:r>
               <a:rPr lang="en-US" sz="1600" b="1" dirty="0">
                 <a:solidFill>
-                  <a:srgbClr val="EAF1FB"/>
+                  <a:srgbClr val="1E2A40"/>
                 </a:solidFill>
                 <a:latin typeface="Microsoft JhengHei" pitchFamily="34" charset="0"/>
                 <a:ea typeface="Microsoft JhengHei" pitchFamily="34" charset="-122"/>
@@ -7537,7 +7537,7 @@
             <a:r>
               <a:rPr lang="en-US" sz="1250" dirty="0">
                 <a:solidFill>
-                  <a:srgbClr val="BCC8DA"/>
+                  <a:srgbClr val="44546D"/>
                 </a:solidFill>
                 <a:latin typeface="Microsoft JhengHei" pitchFamily="34" charset="0"/>
                 <a:ea typeface="Microsoft JhengHei" pitchFamily="34" charset="-122"/>
@@ -7566,18 +7566,18 @@
             </a:avLst>
           </a:prstGeom>
           <a:solidFill>
-            <a:srgbClr val="1B2436"/>
+            <a:srgbClr val="FFFFFF"/>
           </a:solidFill>
           <a:ln w="12700">
             <a:solidFill>
-              <a:srgbClr val="33415C"/>
+              <a:srgbClr val="D7E0EE"/>
             </a:solidFill>
             <a:prstDash val="solid"/>
           </a:ln>
           <a:effectLst>
-            <a:outerShdw sx="100000" sy="100000" kx="0" ky="0" algn="bl" rotWithShape="0" blurRad="114300" dist="38100" dir="5400000">
-              <a:srgbClr val="000000">
-                <a:alpha val="32000"/>
+            <a:outerShdw sx="100000" sy="100000" kx="0" ky="0" algn="bl" rotWithShape="0" blurRad="88900" dist="25400" dir="5400000">
+              <a:srgbClr val="8895AC">
+                <a:alpha val="28000"/>
               </a:srgbClr>
             </a:outerShdw>
           </a:effectLst>
@@ -7598,7 +7598,7 @@
             <a:avLst/>
           </a:prstGeom>
           <a:solidFill>
-            <a:srgbClr val="9A5BD0"/>
+            <a:srgbClr val="8348B8"/>
           </a:solidFill>
           <a:ln/>
         </p:spPr>
@@ -7630,7 +7630,7 @@
             <a:r>
               <a:rPr lang="en-US" sz="1600" b="1" dirty="0">
                 <a:solidFill>
-                  <a:srgbClr val="EAF1FB"/>
+                  <a:srgbClr val="1E2A40"/>
                 </a:solidFill>
                 <a:latin typeface="Microsoft JhengHei" pitchFamily="34" charset="0"/>
                 <a:ea typeface="Microsoft JhengHei" pitchFamily="34" charset="-122"/>
@@ -7669,7 +7669,7 @@
             <a:r>
               <a:rPr lang="en-US" sz="1250" dirty="0">
                 <a:solidFill>
-                  <a:srgbClr val="BCC8DA"/>
+                  <a:srgbClr val="44546D"/>
                 </a:solidFill>
                 <a:latin typeface="Microsoft JhengHei" pitchFamily="34" charset="0"/>
                 <a:ea typeface="Microsoft JhengHei" pitchFamily="34" charset="-122"/>
@@ -7698,18 +7698,18 @@
             </a:avLst>
           </a:prstGeom>
           <a:solidFill>
-            <a:srgbClr val="1B2436"/>
+            <a:srgbClr val="FFFFFF"/>
           </a:solidFill>
           <a:ln w="12700">
             <a:solidFill>
-              <a:srgbClr val="33415C"/>
+              <a:srgbClr val="D7E0EE"/>
             </a:solidFill>
             <a:prstDash val="solid"/>
           </a:ln>
           <a:effectLst>
-            <a:outerShdw sx="100000" sy="100000" kx="0" ky="0" algn="bl" rotWithShape="0" blurRad="114300" dist="38100" dir="5400000">
-              <a:srgbClr val="000000">
-                <a:alpha val="32000"/>
+            <a:outerShdw sx="100000" sy="100000" kx="0" ky="0" algn="bl" rotWithShape="0" blurRad="88900" dist="25400" dir="5400000">
+              <a:srgbClr val="8895AC">
+                <a:alpha val="28000"/>
               </a:srgbClr>
             </a:outerShdw>
           </a:effectLst>
@@ -7730,7 +7730,7 @@
             <a:avLst/>
           </a:prstGeom>
           <a:solidFill>
-            <a:srgbClr val="36A06A"/>
+            <a:srgbClr val="2E9460"/>
           </a:solidFill>
           <a:ln/>
         </p:spPr>
@@ -7762,7 +7762,7 @@
             <a:r>
               <a:rPr lang="en-US" sz="1600" b="1" dirty="0">
                 <a:solidFill>
-                  <a:srgbClr val="EAF1FB"/>
+                  <a:srgbClr val="1E2A40"/>
                 </a:solidFill>
                 <a:latin typeface="Microsoft JhengHei" pitchFamily="34" charset="0"/>
                 <a:ea typeface="Microsoft JhengHei" pitchFamily="34" charset="-122"/>
@@ -7801,7 +7801,7 @@
             <a:r>
               <a:rPr lang="en-US" sz="1250" dirty="0">
                 <a:solidFill>
-                  <a:srgbClr val="BCC8DA"/>
+                  <a:srgbClr val="44546D"/>
                 </a:solidFill>
                 <a:latin typeface="Microsoft JhengHei" pitchFamily="34" charset="0"/>
                 <a:ea typeface="Microsoft JhengHei" pitchFamily="34" charset="-122"/>
@@ -7830,11 +7830,11 @@
             </a:avLst>
           </a:prstGeom>
           <a:solidFill>
-            <a:srgbClr val="232E44"/>
+            <a:srgbClr val="EDF3FB"/>
           </a:solidFill>
           <a:ln w="19050">
             <a:solidFill>
-              <a:srgbClr val="38BDF8"/>
+              <a:srgbClr val="0E9BD6"/>
             </a:solidFill>
             <a:prstDash val="solid"/>
           </a:ln>
@@ -7867,7 +7867,7 @@
             <a:r>
               <a:rPr lang="en-US" sz="1500" dirty="0">
                 <a:solidFill>
-                  <a:srgbClr val="BCC8DA"/>
+                  <a:srgbClr val="44546D"/>
                 </a:solidFill>
                 <a:latin typeface="Microsoft JhengHei" pitchFamily="34" charset="0"/>
                 <a:ea typeface="Microsoft JhengHei" pitchFamily="34" charset="-122"/>
@@ -7881,7 +7881,7 @@
             <a:r>
               <a:rPr lang="en-US" sz="1500" b="1" dirty="0">
                 <a:solidFill>
-                  <a:srgbClr val="38BDF8"/>
+                  <a:srgbClr val="0E9BD6"/>
                 </a:solidFill>
                 <a:latin typeface="Microsoft JhengHei" pitchFamily="34" charset="0"/>
                 <a:ea typeface="Microsoft JhengHei" pitchFamily="34" charset="-122"/>
@@ -7895,7 +7895,7 @@
             <a:r>
               <a:rPr lang="en-US" sz="1500" dirty="0">
                 <a:solidFill>
-                  <a:srgbClr val="BCC8DA"/>
+                  <a:srgbClr val="44546D"/>
                 </a:solidFill>
                 <a:latin typeface="Microsoft JhengHei" pitchFamily="34" charset="0"/>
                 <a:ea typeface="Microsoft JhengHei" pitchFamily="34" charset="-122"/>
@@ -7924,7 +7924,7 @@
           <a:noFill/>
           <a:ln w="12700">
             <a:solidFill>
-              <a:srgbClr val="33415C"/>
+              <a:srgbClr val="D7E0EE"/>
             </a:solidFill>
             <a:prstDash val="solid"/>
           </a:ln>
@@ -7957,7 +7957,7 @@
             <a:r>
               <a:rPr lang="en-US" sz="900" dirty="0">
                 <a:solidFill>
-                  <a:srgbClr val="93A1B8"/>
+                  <a:srgbClr val="6E7C93"/>
                 </a:solidFill>
                 <a:latin typeface="Microsoft JhengHei" pitchFamily="34" charset="0"/>
                 <a:ea typeface="Microsoft JhengHei" pitchFamily="34" charset="-122"/>
@@ -7996,7 +7996,7 @@
             <a:r>
               <a:rPr lang="en-US" sz="900" dirty="0">
                 <a:solidFill>
-                  <a:srgbClr val="93A1B8"/>
+                  <a:srgbClr val="6E7C93"/>
                 </a:solidFill>
                 <a:latin typeface="Microsoft JhengHei" pitchFamily="34" charset="0"/>
                 <a:ea typeface="Microsoft JhengHei" pitchFamily="34" charset="-122"/>
@@ -8022,7 +8022,7 @@
     <p:bg>
       <p:bgPr>
         <a:solidFill>
-          <a:srgbClr val="0E1626"/>
+          <a:srgbClr val="F6F8FC"/>
         </a:solidFill>
       </p:bgPr>
     </p:bg>
@@ -8055,7 +8055,7 @@
             <a:avLst/>
           </a:prstGeom>
           <a:solidFill>
-            <a:srgbClr val="36A06A"/>
+            <a:srgbClr val="2E9460"/>
           </a:solidFill>
           <a:ln/>
         </p:spPr>
@@ -8075,13 +8075,13 @@
             <a:avLst/>
           </a:prstGeom>
           <a:solidFill>
-            <a:srgbClr val="36A06A"/>
+            <a:srgbClr val="2E9460"/>
           </a:solidFill>
           <a:ln/>
           <a:effectLst>
-            <a:outerShdw sx="100000" sy="100000" kx="0" ky="0" algn="bl" rotWithShape="0" blurRad="114300" dist="38100" dir="5400000">
-              <a:srgbClr val="000000">
-                <a:alpha val="32000"/>
+            <a:outerShdw sx="100000" sy="100000" kx="0" ky="0" algn="bl" rotWithShape="0" blurRad="88900" dist="25400" dir="5400000">
+              <a:srgbClr val="8895AC">
+                <a:alpha val="28000"/>
               </a:srgbClr>
             </a:outerShdw>
           </a:effectLst>
@@ -8114,7 +8114,7 @@
             <a:r>
               <a:rPr lang="en-US" sz="1250" b="1" spc="300" kern="0" dirty="0">
                 <a:solidFill>
-                  <a:srgbClr val="36A06A"/>
+                  <a:srgbClr val="2E9460"/>
                 </a:solidFill>
                 <a:latin typeface="Microsoft JhengHei" pitchFamily="34" charset="0"/>
                 <a:ea typeface="Microsoft JhengHei" pitchFamily="34" charset="-122"/>
@@ -8153,7 +8153,7 @@
             <a:r>
               <a:rPr lang="en-US" sz="2900" b="1" dirty="0">
                 <a:solidFill>
-                  <a:srgbClr val="EAF1FB"/>
+                  <a:srgbClr val="1E2A40"/>
                 </a:solidFill>
                 <a:latin typeface="Microsoft JhengHei" pitchFamily="34" charset="0"/>
                 <a:ea typeface="Microsoft JhengHei" pitchFamily="34" charset="-122"/>
@@ -8182,18 +8182,18 @@
             </a:avLst>
           </a:prstGeom>
           <a:solidFill>
-            <a:srgbClr val="1B2436"/>
+            <a:srgbClr val="FFFFFF"/>
           </a:solidFill>
           <a:ln w="12700">
             <a:solidFill>
-              <a:srgbClr val="33415C"/>
+              <a:srgbClr val="D7E0EE"/>
             </a:solidFill>
             <a:prstDash val="solid"/>
           </a:ln>
           <a:effectLst>
-            <a:outerShdw sx="100000" sy="100000" kx="0" ky="0" algn="bl" rotWithShape="0" blurRad="114300" dist="38100" dir="5400000">
-              <a:srgbClr val="000000">
-                <a:alpha val="32000"/>
+            <a:outerShdw sx="100000" sy="100000" kx="0" ky="0" algn="bl" rotWithShape="0" blurRad="88900" dist="25400" dir="5400000">
+              <a:srgbClr val="8895AC">
+                <a:alpha val="28000"/>
               </a:srgbClr>
             </a:outerShdw>
           </a:effectLst>
@@ -8214,7 +8214,7 @@
             <a:avLst/>
           </a:prstGeom>
           <a:solidFill>
-            <a:srgbClr val="38BDF8"/>
+            <a:srgbClr val="0E9BD6"/>
           </a:solidFill>
           <a:ln/>
         </p:spPr>
@@ -8246,7 +8246,7 @@
             <a:r>
               <a:rPr lang="en-US" sz="1700" b="1" dirty="0">
                 <a:solidFill>
-                  <a:srgbClr val="38BDF8"/>
+                  <a:srgbClr val="0E9BD6"/>
                 </a:solidFill>
                 <a:latin typeface="Microsoft JhengHei" pitchFamily="34" charset="0"/>
                 <a:ea typeface="Microsoft JhengHei" pitchFamily="34" charset="-122"/>
@@ -8285,7 +8285,7 @@
             <a:r>
               <a:rPr lang="en-US" sz="1300" dirty="0">
                 <a:solidFill>
-                  <a:srgbClr val="BCC8DA"/>
+                  <a:srgbClr val="44546D"/>
                 </a:solidFill>
                 <a:latin typeface="Microsoft JhengHei" pitchFamily="34" charset="0"/>
                 <a:ea typeface="Microsoft JhengHei" pitchFamily="34" charset="-122"/>
@@ -8314,18 +8314,18 @@
             </a:avLst>
           </a:prstGeom>
           <a:solidFill>
-            <a:srgbClr val="1B2436"/>
+            <a:srgbClr val="FFFFFF"/>
           </a:solidFill>
           <a:ln w="12700">
             <a:solidFill>
-              <a:srgbClr val="33415C"/>
+              <a:srgbClr val="D7E0EE"/>
             </a:solidFill>
             <a:prstDash val="solid"/>
           </a:ln>
           <a:effectLst>
-            <a:outerShdw sx="100000" sy="100000" kx="0" ky="0" algn="bl" rotWithShape="0" blurRad="114300" dist="38100" dir="5400000">
-              <a:srgbClr val="000000">
-                <a:alpha val="32000"/>
+            <a:outerShdw sx="100000" sy="100000" kx="0" ky="0" algn="bl" rotWithShape="0" blurRad="88900" dist="25400" dir="5400000">
+              <a:srgbClr val="8895AC">
+                <a:alpha val="28000"/>
               </a:srgbClr>
             </a:outerShdw>
           </a:effectLst>
@@ -8346,7 +8346,7 @@
             <a:avLst/>
           </a:prstGeom>
           <a:solidFill>
-            <a:srgbClr val="E8923E"/>
+            <a:srgbClr val="D9791C"/>
           </a:solidFill>
           <a:ln/>
         </p:spPr>
@@ -8378,7 +8378,7 @@
             <a:r>
               <a:rPr lang="en-US" sz="1700" b="1" dirty="0">
                 <a:solidFill>
-                  <a:srgbClr val="E8923E"/>
+                  <a:srgbClr val="D9791C"/>
                 </a:solidFill>
                 <a:latin typeface="Microsoft JhengHei" pitchFamily="34" charset="0"/>
                 <a:ea typeface="Microsoft JhengHei" pitchFamily="34" charset="-122"/>
@@ -8417,7 +8417,7 @@
             <a:r>
               <a:rPr lang="en-US" sz="1300" dirty="0">
                 <a:solidFill>
-                  <a:srgbClr val="BCC8DA"/>
+                  <a:srgbClr val="44546D"/>
                 </a:solidFill>
                 <a:latin typeface="Microsoft JhengHei" pitchFamily="34" charset="0"/>
                 <a:ea typeface="Microsoft JhengHei" pitchFamily="34" charset="-122"/>
@@ -8446,18 +8446,18 @@
             </a:avLst>
           </a:prstGeom>
           <a:solidFill>
-            <a:srgbClr val="1B2436"/>
+            <a:srgbClr val="FFFFFF"/>
           </a:solidFill>
           <a:ln w="12700">
             <a:solidFill>
-              <a:srgbClr val="33415C"/>
+              <a:srgbClr val="D7E0EE"/>
             </a:solidFill>
             <a:prstDash val="solid"/>
           </a:ln>
           <a:effectLst>
-            <a:outerShdw sx="100000" sy="100000" kx="0" ky="0" algn="bl" rotWithShape="0" blurRad="114300" dist="38100" dir="5400000">
-              <a:srgbClr val="000000">
-                <a:alpha val="32000"/>
+            <a:outerShdw sx="100000" sy="100000" kx="0" ky="0" algn="bl" rotWithShape="0" blurRad="88900" dist="25400" dir="5400000">
+              <a:srgbClr val="8895AC">
+                <a:alpha val="28000"/>
               </a:srgbClr>
             </a:outerShdw>
           </a:effectLst>
@@ -8478,7 +8478,7 @@
             <a:avLst/>
           </a:prstGeom>
           <a:solidFill>
-            <a:srgbClr val="36A06A"/>
+            <a:srgbClr val="2E9460"/>
           </a:solidFill>
           <a:ln/>
         </p:spPr>
@@ -8510,7 +8510,7 @@
             <a:r>
               <a:rPr lang="en-US" sz="1700" b="1" dirty="0">
                 <a:solidFill>
-                  <a:srgbClr val="36A06A"/>
+                  <a:srgbClr val="2E9460"/>
                 </a:solidFill>
                 <a:latin typeface="Microsoft JhengHei" pitchFamily="34" charset="0"/>
                 <a:ea typeface="Microsoft JhengHei" pitchFamily="34" charset="-122"/>
@@ -8549,7 +8549,7 @@
             <a:r>
               <a:rPr lang="en-US" sz="1300" dirty="0">
                 <a:solidFill>
-                  <a:srgbClr val="BCC8DA"/>
+                  <a:srgbClr val="44546D"/>
                 </a:solidFill>
                 <a:latin typeface="Microsoft JhengHei" pitchFamily="34" charset="0"/>
                 <a:ea typeface="Microsoft JhengHei" pitchFamily="34" charset="-122"/>
@@ -8588,7 +8588,7 @@
             <a:r>
               <a:rPr lang="en-US" sz="1300" i="1" dirty="0">
                 <a:solidFill>
-                  <a:srgbClr val="38BDF8"/>
+                  <a:srgbClr val="0E9BD6"/>
                 </a:solidFill>
                 <a:latin typeface="Microsoft JhengHei" pitchFamily="34" charset="0"/>
                 <a:ea typeface="Microsoft JhengHei" pitchFamily="34" charset="-122"/>
@@ -8617,7 +8617,7 @@
           <a:noFill/>
           <a:ln w="12700">
             <a:solidFill>
-              <a:srgbClr val="33415C"/>
+              <a:srgbClr val="D7E0EE"/>
             </a:solidFill>
             <a:prstDash val="solid"/>
           </a:ln>
@@ -8650,7 +8650,7 @@
             <a:r>
               <a:rPr lang="en-US" sz="900" dirty="0">
                 <a:solidFill>
-                  <a:srgbClr val="93A1B8"/>
+                  <a:srgbClr val="6E7C93"/>
                 </a:solidFill>
                 <a:latin typeface="Microsoft JhengHei" pitchFamily="34" charset="0"/>
                 <a:ea typeface="Microsoft JhengHei" pitchFamily="34" charset="-122"/>
@@ -8689,7 +8689,7 @@
             <a:r>
               <a:rPr lang="en-US" sz="900" dirty="0">
                 <a:solidFill>
-                  <a:srgbClr val="93A1B8"/>
+                  <a:srgbClr val="6E7C93"/>
                 </a:solidFill>
                 <a:latin typeface="Microsoft JhengHei" pitchFamily="34" charset="0"/>
                 <a:ea typeface="Microsoft JhengHei" pitchFamily="34" charset="-122"/>

</xml_diff>